<commit_message>
Tighten CatalogONE study: drop marketing pages, keep architecture and operator evidence
The first draft was 23 pages of lifestyle datasheet spreads. This revision
keeps the eight PLC stages and the Dynamics 365 publish path, and uses
only figures that show architecture, master-catalog publish, or operator
results. Study is now 17 pages.

Co-authored-by: abdelrahman Hamdy <abdoe317111@gmail.com>
</commit_message>
<xml_diff>
--- a/plc_study/PLC_CatalogONE_Presentation.pptx
+++ b/plc_study/PLC_CatalogONE_Presentation.pptx
@@ -14212,8 +14212,8 @@
         </p:nvSpPr>
         <p:spPr>
           <a:xfrm>
-            <a:off x="420624" y="1380744"/>
-            <a:ext cx="5559551" cy="4312642"/>
+            <a:off x="1498980" y="1380744"/>
+            <a:ext cx="3402839" cy="4507992"/>
           </a:xfrm>
           <a:prstGeom prst="rect">
             <a:avLst/>
@@ -14250,7 +14250,7 @@
       </p:sp>
       <p:pic>
         <p:nvPicPr>
-          <p:cNvPr id="8" name="Picture 7" descr="09_modules.png"/>
+          <p:cNvPr id="8" name="Picture 7" descr="09_modules_list.png"/>
           <p:cNvPicPr>
             <a:picLocks noChangeAspect="1"/>
           </p:cNvPicPr>
@@ -14264,8 +14264,8 @@
         </p:blipFill>
         <p:spPr>
           <a:xfrm>
-            <a:off x="457200" y="1417320"/>
-            <a:ext cx="5486399" cy="4239490"/>
+            <a:off x="1535556" y="1417320"/>
+            <a:ext cx="3329687" cy="4434840"/>
           </a:xfrm>
           <a:prstGeom prst="rect">
             <a:avLst/>
@@ -14280,7 +14280,7 @@
         </p:nvSpPr>
         <p:spPr>
           <a:xfrm>
-            <a:off x="457200" y="5711674"/>
+            <a:off x="457200" y="5907024"/>
             <a:ext cx="5486400" cy="411480"/>
           </a:xfrm>
           <a:prstGeom prst="rect">

</xml_diff>

<commit_message>
Correct CatalogONE study: CRM publish is generic; Dynamics is CEP
The deck had mixed CatalogONE's unnamed "customer's CRM" publish with
CEP putting Catalog next to Dynamics 365. Split those facts. Add PLDT
as live CEP customer-care evidence (IDC Unified Case Management), not
as a CatalogONE-to-Dynamics catalog connector.

Co-authored-by: abdelrahman Hamdy <abdoe317111@gmail.com>
</commit_message>
<xml_diff>
--- a/plc_study/PLC_CatalogONE_Presentation.pptx
+++ b/plc_study/PLC_CatalogONE_Presentation.pptx
@@ -518,7 +518,7 @@
           <a:lstStyle/>
           <a:p>
             <a:r>
-              <a:t>CatalogONE is the PLC. Dynamics 365 stays the CRM. Walk the manager through that split, then the eight stages, then the publish path.</a:t>
+              <a:t>CatalogONE is the PLC. It publishes to consuming apps and 'the customer's CRM'. Dynamics 365 is named on the Amdocs–Microsoft CEP, not as a CatalogONE connector.</a:t>
             </a:r>
           </a:p>
         </p:txBody>
@@ -588,7 +588,7 @@
           <a:lstStyle/>
           <a:p>
             <a:r>
-              <a:t>Lead with the split the manager cares about: we keep Dynamics.</a:t>
+              <a:t>Do not say CatalogONE sends data to Dynamics. Say: publishes to CRM; CEP names Dynamics.</a:t>
             </a:r>
           </a:p>
         </p:txBody>
@@ -3829,7 +3829,7 @@
         <p:spPr>
           <a:xfrm>
             <a:off x="1005840" y="3749039"/>
-            <a:ext cx="10058400" cy="640080"/>
+            <a:ext cx="10515600" cy="822960"/>
           </a:xfrm>
           <a:prstGeom prst="rect">
             <a:avLst/>
@@ -3844,12 +3844,12 @@
           <a:p>
             <a:pPr algn="l"/>
             <a:r>
-              <a:rPr sz="2200" b="0">
+              <a:rPr sz="2000" b="0">
                 <a:solidFill>
                   <a:srgbClr val="E8F0F8"/>
                 </a:solidFill>
               </a:rPr>
-              <a:t>From idea to Dynamics 365: a catalog-only PLC that publishes into CRM</a:t>
+              <a:t>A catalog-only PLC that publishes to consuming applications — including the customer's CRM</a:t>
             </a:r>
           </a:p>
         </p:txBody>
@@ -3883,7 +3883,7 @@
                   <a:srgbClr val="E8F0F8"/>
                 </a:solidFill>
               </a:rPr>
-              <a:t>Prepared by: [Your name]   |   October 2026</a:t>
+              <a:t>Prepared by: [Your name]   |   October 2026   |   Draft 3</a:t>
             </a:r>
           </a:p>
         </p:txBody>
@@ -3979,7 +3979,7 @@
                   <a:srgbClr val="0C294B"/>
                 </a:solidFill>
               </a:rPr>
-              <a:t>Approval gates: nothing reaches Dynamics by accident</a:t>
+              <a:t>Approval gates: nothing is published by accident</a:t>
             </a:r>
           </a:p>
         </p:txBody>
@@ -4047,7 +4047,7 @@
                   <a:srgbClr val="5F5A6B"/>
                 </a:solidFill>
               </a:rPr>
-              <a:t>PLC study  |  Amdocs CatalogONE: from idea to Dynamics 365</a:t>
+              <a:t>PLC study  |  Amdocs CatalogONE: from idea to CRM</a:t>
             </a:r>
           </a:p>
         </p:txBody>
@@ -5083,7 +5083,7 @@
                   <a:srgbClr val="0C294B"/>
                 </a:solidFill>
               </a:rPr>
-              <a:t>Dynamics consumes the approved product. It never re-creates it.</a:t>
+              <a:t>The catalog publishes. CRM consumes. Two documented facts.</a:t>
             </a:r>
           </a:p>
         </p:txBody>
@@ -5117,7 +5117,7 @@
                   <a:srgbClr val="5F5A6B"/>
                 </a:solidFill>
               </a:rPr>
-              <a:t>CatalogONE is the source of truth. Dynamics 365 is the sales channel.</a:t>
+              <a:t>CatalogONE names CRM. CEP names Dynamics 365. They are not the same sentence.</a:t>
             </a:r>
           </a:p>
         </p:txBody>
@@ -5151,7 +5151,7 @@
                   <a:srgbClr val="5F5A6B"/>
                 </a:solidFill>
               </a:rPr>
-              <a:t>PLC study  |  Amdocs CatalogONE: from idea to Dynamics 365</a:t>
+              <a:t>PLC study  |  Amdocs CatalogONE: from idea to CRM</a:t>
             </a:r>
           </a:p>
         </p:txBody>
@@ -5232,11 +5232,11 @@
           <a:p>
             <a:pPr algn="ctr">
               <a:spcAft>
-                <a:spcPts val="880"/>
+                <a:spcPts val="825"/>
               </a:spcAft>
             </a:pPr>
             <a:r>
-              <a:rPr sz="1600" b="1">
+              <a:rPr sz="1500" b="1">
                 <a:solidFill>
                   <a:srgbClr val="FFFFFF"/>
                 </a:solidFill>
@@ -5247,11 +5247,11 @@
           <a:p>
             <a:pPr algn="ctr">
               <a:spcAft>
-                <a:spcPts val="880"/>
+                <a:spcPts val="825"/>
               </a:spcAft>
             </a:pPr>
             <a:r>
-              <a:rPr sz="1600" b="1">
+              <a:rPr sz="1500" b="1">
                 <a:solidFill>
                   <a:srgbClr val="FFFFFF"/>
                 </a:solidFill>
@@ -5262,11 +5262,11 @@
           <a:p>
             <a:pPr algn="ctr">
               <a:spcAft>
-                <a:spcPts val="880"/>
+                <a:spcPts val="825"/>
               </a:spcAft>
             </a:pPr>
             <a:r>
-              <a:rPr sz="1600" b="1">
+              <a:rPr sz="1500" b="1">
                 <a:solidFill>
                   <a:srgbClr val="FFFFFF"/>
                 </a:solidFill>
@@ -5277,16 +5277,16 @@
           <a:p>
             <a:pPr algn="ctr">
               <a:spcAft>
-                <a:spcPts val="880"/>
+                <a:spcPts val="825"/>
               </a:spcAft>
             </a:pPr>
             <a:r>
-              <a:rPr sz="1600" b="1">
+              <a:rPr sz="1500" b="1">
                 <a:solidFill>
                   <a:srgbClr val="FFFFFF"/>
                 </a:solidFill>
               </a:rPr>
-              <a:t>Only Active products are published</a:t>
+              <a:t>Publishes Active products to consuming applications</a:t>
             </a:r>
           </a:p>
         </p:txBody>
@@ -5751,41 +5751,41 @@
           <a:p>
             <a:pPr algn="ctr">
               <a:spcAft>
-                <a:spcPts val="825"/>
+                <a:spcPts val="770"/>
               </a:spcAft>
             </a:pPr>
             <a:r>
-              <a:rPr sz="1500" b="1">
+              <a:rPr sz="1400" b="1">
                 <a:solidFill>
                   <a:srgbClr val="FFFFFF"/>
                 </a:solidFill>
               </a:rPr>
-              <a:t>Dynamics 365</a:t>
+              <a:t>Customer's CRM</a:t>
             </a:r>
           </a:p>
           <a:p>
             <a:pPr algn="ctr">
               <a:spcAft>
-                <a:spcPts val="825"/>
+                <a:spcPts val="770"/>
               </a:spcAft>
             </a:pPr>
             <a:r>
-              <a:rPr sz="1500" b="1">
+              <a:rPr sz="1400" b="1">
                 <a:solidFill>
                   <a:srgbClr val="FFFFFF"/>
                 </a:solidFill>
               </a:rPr>
-              <a:t>Sales</a:t>
+              <a:t>(unnamed on CatalogONE)</a:t>
             </a:r>
           </a:p>
           <a:p>
             <a:pPr algn="ctr">
               <a:spcAft>
-                <a:spcPts val="825"/>
+                <a:spcPts val="770"/>
               </a:spcAft>
             </a:pPr>
             <a:r>
-              <a:rPr sz="1500" b="1">
+              <a:rPr sz="1400" b="1">
                 <a:solidFill>
                   <a:srgbClr val="FFFFFF"/>
                 </a:solidFill>
@@ -5796,16 +5796,16 @@
           <a:p>
             <a:pPr algn="ctr">
               <a:spcAft>
-                <a:spcPts val="825"/>
+                <a:spcPts val="770"/>
               </a:spcAft>
             </a:pPr>
             <a:r>
-              <a:rPr sz="1500" b="1">
+              <a:rPr sz="1400" b="1">
                 <a:solidFill>
                   <a:srgbClr val="FFFFFF"/>
                 </a:solidFill>
               </a:rPr>
-              <a:t>Quote, order and contract use the catalog definition</a:t>
+              <a:t>Dynamics 365 only where CEP is the platform</a:t>
             </a:r>
           </a:p>
         </p:txBody>
@@ -5839,7 +5839,7 @@
                   <a:srgbClr val="5F5A6B"/>
                 </a:solidFill>
               </a:rPr>
-              <a:t>Amdocs–Microsoft CEP: "unified Catalog, CPQ, Commerce and Order Management" plus "Dynamics 365 modules focused on sales, marketing, and customer service". CatalogONE Centralized publishes to consuming applications.</a:t>
+              <a:t>Fact 1 — CatalogONE: "publishing catalog information to multiple consuming applications" and "integration to … the customer's CRM solution". Fact 2 — CEP: unified Catalog plus "Dynamics 365 modules focused on sales, marketing, and customer service".</a:t>
             </a:r>
           </a:p>
         </p:txBody>
@@ -5935,7 +5935,7 @@
                   <a:srgbClr val="0C294B"/>
                 </a:solidFill>
               </a:rPr>
-              <a:t>How the hand-over works</a:t>
+              <a:t>How CatalogONE publishes — destination is CRM, not named as Dynamics</a:t>
             </a:r>
           </a:p>
         </p:txBody>
@@ -6003,7 +6003,7 @@
                   <a:srgbClr val="5F5A6B"/>
                 </a:solidFill>
               </a:rPr>
-              <a:t>PLC study  |  Amdocs CatalogONE: from idea to Dynamics 365</a:t>
+              <a:t>PLC study  |  Amdocs CatalogONE: from idea to CRM</a:t>
             </a:r>
           </a:p>
         </p:txBody>
@@ -6062,8 +6062,8 @@
               </a:tblPr>
               <a:tblGrid>
                 <a:gridCol w="3017520"/>
-                <a:gridCol w="2377440"/>
-                <a:gridCol w="5760720"/>
+                <a:gridCol w="2926080"/>
+                <a:gridCol w="5212080"/>
               </a:tblGrid>
               <a:tr h="457200">
                 <a:tc>
@@ -6163,7 +6163,7 @@
                             <a:srgbClr val="26222E"/>
                           </a:solidFill>
                         </a:rPr>
-                        <a:t>Catalog to Dynamics</a:t>
+                        <a:t>Catalog → consuming apps</a:t>
                       </a:r>
                     </a:p>
                   </a:txBody>
@@ -6228,7 +6228,7 @@
                             <a:srgbClr val="26222E"/>
                           </a:solidFill>
                         </a:rPr>
-                        <a:t>Catalog to Dynamics</a:t>
+                        <a:t>Catalog → downstream systems</a:t>
                       </a:r>
                     </a:p>
                   </a:txBody>
@@ -6293,7 +6293,7 @@
                             <a:srgbClr val="26222E"/>
                           </a:solidFill>
                         </a:rPr>
-                        <a:t>Catalog to Dynamics</a:t>
+                        <a:t>Catalog → any TMF consumer</a:t>
                       </a:r>
                     </a:p>
                   </a:txBody>
@@ -6358,7 +6358,7 @@
                             <a:srgbClr val="26222E"/>
                           </a:solidFill>
                         </a:rPr>
-                        <a:t>Catalog to Dynamics</a:t>
+                        <a:t>Catalog → subscribers</a:t>
                       </a:r>
                     </a:p>
                   </a:txBody>
@@ -6423,7 +6423,7 @@
                             <a:srgbClr val="26222E"/>
                           </a:solidFill>
                         </a:rPr>
-                        <a:t>Dynamics to catalog</a:t>
+                        <a:t>CRM / CPQ → catalog</a:t>
                       </a:r>
                     </a:p>
                   </a:txBody>
@@ -6488,7 +6488,7 @@
                             <a:srgbClr val="26222E"/>
                           </a:solidFill>
                         </a:rPr>
-                        <a:t>Dynamics to order mgmt</a:t>
+                        <a:t>CRM / CPQ → order mgmt</a:t>
                       </a:r>
                     </a:p>
                   </a:txBody>
@@ -6747,7 +6747,7 @@
                   <a:srgbClr val="FFFFFF"/>
                 </a:solidFill>
               </a:rPr>
-              <a:t>Dynamics reads TMF620</a:t>
+              <a:t>CRM reads TMF620</a:t>
             </a:r>
           </a:p>
         </p:txBody>
@@ -6835,7 +6835,7 @@
                   <a:srgbClr val="FFFFFF"/>
                 </a:solidFill>
               </a:rPr>
-              <a:t>AM quotes in Sales</a:t>
+              <a:t>AM quotes in CRM</a:t>
             </a:r>
           </a:p>
         </p:txBody>
@@ -7019,7 +7019,7 @@
                   <a:srgbClr val="0C294B"/>
                 </a:solidFill>
               </a:rPr>
-              <a:t>What sits around the catalog</a:t>
+              <a:t>What sits around the catalog — on CEP, not on a CatalogONE datasheet</a:t>
             </a:r>
           </a:p>
         </p:txBody>
@@ -7053,7 +7053,7 @@
                   <a:srgbClr val="5F5A6B"/>
                 </a:solidFill>
               </a:rPr>
-              <a:t>Digital Enterprise Catalog (Amdocs) and Sales management (Dynamics) on one platform</a:t>
+              <a:t>Digital Enterprise Catalog (Amdocs) and Sales management (Dynamics 365) on one CEP platform</a:t>
             </a:r>
           </a:p>
         </p:txBody>
@@ -7087,7 +7087,7 @@
                   <a:srgbClr val="5F5A6B"/>
                 </a:solidFill>
               </a:rPr>
-              <a:t>PLC study  |  Amdocs CatalogONE: from idea to Dynamics 365</a:t>
+              <a:t>PLC study  |  Amdocs CatalogONE: from idea to CRM</a:t>
             </a:r>
           </a:p>
         </p:txBody>
@@ -7387,7 +7387,7 @@
                   <a:srgbClr val="5F5A6B"/>
                 </a:solidFill>
               </a:rPr>
-              <a:t>PLC study  |  Amdocs CatalogONE: from idea to Dynamics 365</a:t>
+              <a:t>PLC study  |  Amdocs CatalogONE: from idea to CRM</a:t>
             </a:r>
           </a:p>
         </p:txBody>
@@ -7577,7 +7577,7 @@
                   <a:srgbClr val="5F5A6B"/>
                 </a:solidFill>
               </a:rPr>
-              <a:t>In CatalogONE, not in Dynamics</a:t>
+              <a:t>In CatalogONE, not in CRM</a:t>
             </a:r>
           </a:p>
         </p:txBody>
@@ -7855,7 +7855,7 @@
                   <a:srgbClr val="0C294B"/>
                 </a:solidFill>
               </a:rPr>
-              <a:t>Event to Dynamics</a:t>
+              <a:t>Event to CRM</a:t>
             </a:r>
           </a:p>
         </p:txBody>
@@ -8270,7 +8270,7 @@
                   <a:srgbClr val="0C294B"/>
                 </a:solidFill>
               </a:rPr>
-              <a:t>Dynamics side: </a:t>
+              <a:t>If the CRM is Dynamics 365 [E]: </a:t>
             </a:r>
             <a:r>
               <a:rPr sz="1500">
@@ -8278,7 +8278,7 @@
                   <a:srgbClr val="26222E"/>
                 </a:solidFill>
               </a:rPr>
-              <a:t>new version maps to Under Revision, then Active. Retired catalog versions are Retired in Dynamics and drop off the quote screen.</a:t>
+              <a:t>new version maps to Under Revision, then Active. Retired catalog versions are Retired and drop off the quote screen.</a:t>
             </a:r>
           </a:p>
           <a:p>
@@ -8397,7 +8397,7 @@
                   <a:srgbClr val="0C294B"/>
                 </a:solidFill>
               </a:rPr>
-              <a:t>Mapping CatalogONE onto Dynamics 365 Sales</a:t>
+              <a:t>Example only: TMF620 items on Dynamics 365 Sales [E]</a:t>
             </a:r>
           </a:p>
         </p:txBody>
@@ -8431,7 +8431,7 @@
                   <a:srgbClr val="5F5A6B"/>
                 </a:solidFill>
               </a:rPr>
-              <a:t>Study, design, test and approval stay in the catalog. Dynamics receives sellable products.</a:t>
+              <a:t>Not a vendor connector spec. Same pattern as any TMF620 catalog, if Dynamics is the CRM.</a:t>
             </a:r>
           </a:p>
         </p:txBody>
@@ -8465,7 +8465,7 @@
                   <a:srgbClr val="5F5A6B"/>
                 </a:solidFill>
               </a:rPr>
-              <a:t>PLC study  |  Amdocs CatalogONE: from idea to Dynamics 365</a:t>
+              <a:t>PLC study  |  Amdocs CatalogONE: from idea to CRM</a:t>
             </a:r>
           </a:p>
         </p:txBody>
@@ -8662,7 +8662,7 @@
                   <a:srgbClr val="FFFFFF"/>
                 </a:solidFill>
               </a:rPr>
-              <a:t>CEP / Dataverse</a:t>
+              <a:t>Integration</a:t>
             </a:r>
           </a:p>
           <a:p>
@@ -8677,7 +8677,7 @@
                   <a:srgbClr val="FFFFFF"/>
                 </a:solidFill>
               </a:rPr>
-              <a:t>maps and syncs</a:t>
+              <a:t>maps into Dataverse</a:t>
             </a:r>
           </a:p>
         </p:txBody>
@@ -8818,7 +8818,7 @@
                   <a:srgbClr val="5F5A6B"/>
                 </a:solidFill>
               </a:rPr>
-              <a:t>Pre-built in the Amdocs–Microsoft platform; not a custom CRM replacement</a:t>
+              <a:t>Pre-built Catalog+Dynamics is CEP. Not a CatalogONE AppSource connector.</a:t>
             </a:r>
           </a:p>
         </p:txBody>
@@ -8857,7 +8857,7 @@
                             <a:srgbClr val="FFFFFF"/>
                           </a:solidFill>
                         </a:rPr>
-                        <a:t>CatalogONE / TMF620</a:t>
+                        <a:t>Catalog / TMF620 item</a:t>
                       </a:r>
                     </a:p>
                   </a:txBody>
@@ -8878,7 +8878,7 @@
                             <a:srgbClr val="FFFFFF"/>
                           </a:solidFill>
                         </a:rPr>
-                        <a:t>Dynamics 365 Sales entity</a:t>
+                        <a:t>Dynamics 365 Sales entity [M] — example [E]</a:t>
                       </a:r>
                     </a:p>
                   </a:txBody>
@@ -9142,7 +9142,7 @@
                   <a:srgbClr val="0C294B"/>
                 </a:solidFill>
               </a:rPr>
-              <a:t>Dynamics statuses are Draft, Active, Under Revision, Retired. Everything before Active stays in CatalogONE.</a:t>
+              <a:t>Two paths: buy CEP (Catalog next to Dynamics, documented) or keep Dynamics and integrate via TMF620 / Kafka (CatalogONE pattern for any CRM).</a:t>
             </a:r>
           </a:p>
         </p:txBody>
@@ -9251,8 +9251,8 @@
         </p:nvSpPr>
         <p:spPr>
           <a:xfrm>
-            <a:off x="548640" y="6446520"/>
-            <a:ext cx="8686800" cy="274320"/>
+            <a:off x="548640" y="914400"/>
+            <a:ext cx="10972800" cy="411480"/>
           </a:xfrm>
           <a:prstGeom prst="rect">
             <a:avLst/>
@@ -9267,12 +9267,12 @@
           <a:p>
             <a:pPr algn="l"/>
             <a:r>
-              <a:rPr sz="1000" b="0">
+              <a:rPr sz="1500" b="0">
                 <a:solidFill>
                   <a:srgbClr val="5F5A6B"/>
                 </a:solidFill>
               </a:rPr>
-              <a:t>PLC study  |  Amdocs CatalogONE: from idea to Dynamics 365</a:t>
+              <a:t>CatalogONE cases first. PLDT is CEP customer care with Dynamics 365 — not a CatalogONE catalog feed.</a:t>
             </a:r>
           </a:p>
         </p:txBody>
@@ -9285,8 +9285,8 @@
         </p:nvSpPr>
         <p:spPr>
           <a:xfrm>
-            <a:off x="10698480" y="6446520"/>
-            <a:ext cx="914400" cy="274320"/>
+            <a:off x="548640" y="6446520"/>
+            <a:ext cx="8686800" cy="274320"/>
           </a:xfrm>
           <a:prstGeom prst="rect">
             <a:avLst/>
@@ -9299,6 +9299,40 @@
           </a:bodyPr>
           <a:lstStyle/>
           <a:p>
+            <a:pPr algn="l"/>
+            <a:r>
+              <a:rPr sz="1000" b="0">
+                <a:solidFill>
+                  <a:srgbClr val="5F5A6B"/>
+                </a:solidFill>
+              </a:rPr>
+              <a:t>PLC study  |  Amdocs CatalogONE: from idea to CRM</a:t>
+            </a:r>
+          </a:p>
+        </p:txBody>
+      </p:sp>
+      <p:sp>
+        <p:nvSpPr>
+          <p:cNvPr id="6" name="TextBox 5"/>
+          <p:cNvSpPr txBox="1"/>
+          <p:nvPr/>
+        </p:nvSpPr>
+        <p:spPr>
+          <a:xfrm>
+            <a:off x="10698480" y="6446520"/>
+            <a:ext cx="914400" cy="274320"/>
+          </a:xfrm>
+          <a:prstGeom prst="rect">
+            <a:avLst/>
+          </a:prstGeom>
+          <a:noFill/>
+        </p:spPr>
+        <p:txBody>
+          <a:bodyPr wrap="square" anchor="t" lIns="73152" rIns="73152" tIns="36576" bIns="36576">
+            <a:spAutoFit/>
+          </a:bodyPr>
+          <a:lstStyle/>
+          <a:p>
             <a:pPr algn="r"/>
             <a:r>
               <a:rPr sz="1000" b="0">
@@ -9313,14 +9347,14 @@
       </p:sp>
       <p:sp>
         <p:nvSpPr>
-          <p:cNvPr id="6" name="Rectangle 5"/>
+          <p:cNvPr id="7" name="Rectangle 6"/>
           <p:cNvSpPr/>
           <p:nvPr/>
         </p:nvSpPr>
         <p:spPr>
           <a:xfrm>
-            <a:off x="502920" y="1325880"/>
-            <a:ext cx="6858000" cy="1115568"/>
+            <a:off x="502920" y="1371600"/>
+            <a:ext cx="6858000" cy="1024128"/>
           </a:xfrm>
           <a:prstGeom prst="rect">
             <a:avLst/>
@@ -9357,14 +9391,14 @@
       </p:sp>
       <p:sp>
         <p:nvSpPr>
-          <p:cNvPr id="7" name="Rectangle 6"/>
+          <p:cNvPr id="8" name="Rectangle 7"/>
           <p:cNvSpPr/>
           <p:nvPr/>
         </p:nvSpPr>
         <p:spPr>
           <a:xfrm>
-            <a:off x="502920" y="1325880"/>
-            <a:ext cx="109728" cy="1115568"/>
+            <a:off x="502920" y="1371600"/>
+            <a:ext cx="109728" cy="1024128"/>
           </a:xfrm>
           <a:prstGeom prst="rect">
             <a:avLst/>
@@ -9401,14 +9435,14 @@
       </p:sp>
       <p:sp>
         <p:nvSpPr>
-          <p:cNvPr id="8" name="TextBox 7"/>
+          <p:cNvPr id="9" name="TextBox 8"/>
           <p:cNvSpPr txBox="1"/>
           <p:nvPr/>
         </p:nvSpPr>
         <p:spPr>
           <a:xfrm>
-            <a:off x="777240" y="1399032"/>
-            <a:ext cx="6446520" cy="320040"/>
+            <a:off x="777240" y="1426464"/>
+            <a:ext cx="6446520" cy="292608"/>
           </a:xfrm>
           <a:prstGeom prst="rect">
             <a:avLst/>
@@ -9423,7 +9457,7 @@
           <a:p>
             <a:pPr algn="l"/>
             <a:r>
-              <a:rPr sz="1800" b="1">
+              <a:rPr sz="1600" b="1">
                 <a:solidFill>
                   <a:srgbClr val="0C294B"/>
                 </a:solidFill>
@@ -9435,14 +9469,14 @@
       </p:sp>
       <p:sp>
         <p:nvSpPr>
-          <p:cNvPr id="9" name="TextBox 8"/>
+          <p:cNvPr id="10" name="TextBox 9"/>
           <p:cNvSpPr txBox="1"/>
           <p:nvPr/>
         </p:nvSpPr>
         <p:spPr>
           <a:xfrm>
-            <a:off x="777240" y="1709928"/>
-            <a:ext cx="6446520" cy="256032"/>
+            <a:off x="777240" y="1700784"/>
+            <a:ext cx="6446520" cy="237744"/>
           </a:xfrm>
           <a:prstGeom prst="rect">
             <a:avLst/>
@@ -9469,14 +9503,14 @@
       </p:sp>
       <p:sp>
         <p:nvSpPr>
-          <p:cNvPr id="10" name="TextBox 9"/>
+          <p:cNvPr id="11" name="TextBox 10"/>
           <p:cNvSpPr txBox="1"/>
           <p:nvPr/>
         </p:nvSpPr>
         <p:spPr>
           <a:xfrm>
-            <a:off x="777240" y="1984248"/>
-            <a:ext cx="6446520" cy="384048"/>
+            <a:off x="777240" y="1975104"/>
+            <a:ext cx="6446520" cy="347472"/>
           </a:xfrm>
           <a:prstGeom prst="rect">
             <a:avLst/>
@@ -9491,7 +9525,7 @@
           <a:p>
             <a:pPr algn="l"/>
             <a:r>
-              <a:rPr sz="1400" b="1">
+              <a:rPr sz="1300" b="1">
                 <a:solidFill>
                   <a:srgbClr val="26222E"/>
                 </a:solidFill>
@@ -9503,14 +9537,14 @@
       </p:sp>
       <p:sp>
         <p:nvSpPr>
-          <p:cNvPr id="11" name="Rectangle 10"/>
+          <p:cNvPr id="12" name="Rectangle 11"/>
           <p:cNvSpPr/>
           <p:nvPr/>
         </p:nvSpPr>
         <p:spPr>
           <a:xfrm>
-            <a:off x="502920" y="2560320"/>
-            <a:ext cx="6858000" cy="1115568"/>
+            <a:off x="502920" y="2487168"/>
+            <a:ext cx="6858000" cy="1024128"/>
           </a:xfrm>
           <a:prstGeom prst="rect">
             <a:avLst/>
@@ -9547,14 +9581,14 @@
       </p:sp>
       <p:sp>
         <p:nvSpPr>
-          <p:cNvPr id="12" name="Rectangle 11"/>
+          <p:cNvPr id="13" name="Rectangle 12"/>
           <p:cNvSpPr/>
           <p:nvPr/>
         </p:nvSpPr>
         <p:spPr>
           <a:xfrm>
-            <a:off x="502920" y="2560320"/>
-            <a:ext cx="109728" cy="1115568"/>
+            <a:off x="502920" y="2487168"/>
+            <a:ext cx="109728" cy="1024128"/>
           </a:xfrm>
           <a:prstGeom prst="rect">
             <a:avLst/>
@@ -9591,14 +9625,14 @@
       </p:sp>
       <p:sp>
         <p:nvSpPr>
-          <p:cNvPr id="13" name="TextBox 12"/>
+          <p:cNvPr id="14" name="TextBox 13"/>
           <p:cNvSpPr txBox="1"/>
           <p:nvPr/>
         </p:nvSpPr>
         <p:spPr>
           <a:xfrm>
-            <a:off x="777240" y="2633472"/>
-            <a:ext cx="6446520" cy="320040"/>
+            <a:off x="777240" y="2542032"/>
+            <a:ext cx="6446520" cy="292608"/>
           </a:xfrm>
           <a:prstGeom prst="rect">
             <a:avLst/>
@@ -9613,7 +9647,7 @@
           <a:p>
             <a:pPr algn="l"/>
             <a:r>
-              <a:rPr sz="1800" b="1">
+              <a:rPr sz="1600" b="1">
                 <a:solidFill>
                   <a:srgbClr val="0C294B"/>
                 </a:solidFill>
@@ -9625,14 +9659,14 @@
       </p:sp>
       <p:sp>
         <p:nvSpPr>
-          <p:cNvPr id="14" name="TextBox 13"/>
+          <p:cNvPr id="15" name="TextBox 14"/>
           <p:cNvSpPr txBox="1"/>
           <p:nvPr/>
         </p:nvSpPr>
         <p:spPr>
           <a:xfrm>
-            <a:off x="777240" y="2944368"/>
-            <a:ext cx="6446520" cy="256032"/>
+            <a:off x="777240" y="2816352"/>
+            <a:ext cx="6446520" cy="237744"/>
           </a:xfrm>
           <a:prstGeom prst="rect">
             <a:avLst/>
@@ -9659,14 +9693,14 @@
       </p:sp>
       <p:sp>
         <p:nvSpPr>
-          <p:cNvPr id="15" name="TextBox 14"/>
+          <p:cNvPr id="16" name="TextBox 15"/>
           <p:cNvSpPr txBox="1"/>
           <p:nvPr/>
         </p:nvSpPr>
         <p:spPr>
           <a:xfrm>
-            <a:off x="777240" y="3218688"/>
-            <a:ext cx="6446520" cy="384048"/>
+            <a:off x="777240" y="3090672"/>
+            <a:ext cx="6446520" cy="347472"/>
           </a:xfrm>
           <a:prstGeom prst="rect">
             <a:avLst/>
@@ -9681,7 +9715,7 @@
           <a:p>
             <a:pPr algn="l"/>
             <a:r>
-              <a:rPr sz="1400" b="1">
+              <a:rPr sz="1300" b="1">
                 <a:solidFill>
                   <a:srgbClr val="26222E"/>
                 </a:solidFill>
@@ -9693,14 +9727,14 @@
       </p:sp>
       <p:sp>
         <p:nvSpPr>
-          <p:cNvPr id="16" name="Rectangle 15"/>
+          <p:cNvPr id="17" name="Rectangle 16"/>
           <p:cNvSpPr/>
           <p:nvPr/>
         </p:nvSpPr>
         <p:spPr>
           <a:xfrm>
-            <a:off x="502920" y="3794760"/>
-            <a:ext cx="6858000" cy="1115568"/>
+            <a:off x="502920" y="3602736"/>
+            <a:ext cx="6858000" cy="1024128"/>
           </a:xfrm>
           <a:prstGeom prst="rect">
             <a:avLst/>
@@ -9737,14 +9771,14 @@
       </p:sp>
       <p:sp>
         <p:nvSpPr>
-          <p:cNvPr id="17" name="Rectangle 16"/>
+          <p:cNvPr id="18" name="Rectangle 17"/>
           <p:cNvSpPr/>
           <p:nvPr/>
         </p:nvSpPr>
         <p:spPr>
           <a:xfrm>
-            <a:off x="502920" y="3794760"/>
-            <a:ext cx="109728" cy="1115568"/>
+            <a:off x="502920" y="3602736"/>
+            <a:ext cx="109728" cy="1024128"/>
           </a:xfrm>
           <a:prstGeom prst="rect">
             <a:avLst/>
@@ -9781,14 +9815,14 @@
       </p:sp>
       <p:sp>
         <p:nvSpPr>
-          <p:cNvPr id="18" name="TextBox 17"/>
+          <p:cNvPr id="19" name="TextBox 18"/>
           <p:cNvSpPr txBox="1"/>
           <p:nvPr/>
         </p:nvSpPr>
         <p:spPr>
           <a:xfrm>
-            <a:off x="777240" y="3867912"/>
-            <a:ext cx="6446520" cy="320040"/>
+            <a:off x="777240" y="3657600"/>
+            <a:ext cx="6446520" cy="292608"/>
           </a:xfrm>
           <a:prstGeom prst="rect">
             <a:avLst/>
@@ -9803,7 +9837,7 @@
           <a:p>
             <a:pPr algn="l"/>
             <a:r>
-              <a:rPr sz="1800" b="1">
+              <a:rPr sz="1600" b="1">
                 <a:solidFill>
                   <a:srgbClr val="0C294B"/>
                 </a:solidFill>
@@ -9815,14 +9849,14 @@
       </p:sp>
       <p:sp>
         <p:nvSpPr>
-          <p:cNvPr id="19" name="TextBox 18"/>
+          <p:cNvPr id="20" name="TextBox 19"/>
           <p:cNvSpPr txBox="1"/>
           <p:nvPr/>
         </p:nvSpPr>
         <p:spPr>
           <a:xfrm>
-            <a:off x="777240" y="4178808"/>
-            <a:ext cx="6446520" cy="256032"/>
+            <a:off x="777240" y="3931920"/>
+            <a:ext cx="6446520" cy="237744"/>
           </a:xfrm>
           <a:prstGeom prst="rect">
             <a:avLst/>
@@ -9849,14 +9883,14 @@
       </p:sp>
       <p:sp>
         <p:nvSpPr>
-          <p:cNvPr id="20" name="TextBox 19"/>
+          <p:cNvPr id="21" name="TextBox 20"/>
           <p:cNvSpPr txBox="1"/>
           <p:nvPr/>
         </p:nvSpPr>
         <p:spPr>
           <a:xfrm>
-            <a:off x="777240" y="4453128"/>
-            <a:ext cx="6446520" cy="384048"/>
+            <a:off x="777240" y="4206240"/>
+            <a:ext cx="6446520" cy="347472"/>
           </a:xfrm>
           <a:prstGeom prst="rect">
             <a:avLst/>
@@ -9871,7 +9905,7 @@
           <a:p>
             <a:pPr algn="l"/>
             <a:r>
-              <a:rPr sz="1400" b="1">
+              <a:rPr sz="1300" b="1">
                 <a:solidFill>
                   <a:srgbClr val="26222E"/>
                 </a:solidFill>
@@ -9883,14 +9917,204 @@
       </p:sp>
       <p:sp>
         <p:nvSpPr>
-          <p:cNvPr id="21" name="Rectangle 20"/>
+          <p:cNvPr id="22" name="Rectangle 21"/>
           <p:cNvSpPr/>
           <p:nvPr/>
         </p:nvSpPr>
         <p:spPr>
           <a:xfrm>
-            <a:off x="7922172" y="1243584"/>
-            <a:ext cx="3403775" cy="4782312"/>
+            <a:off x="502920" y="4718304"/>
+            <a:ext cx="6858000" cy="1024128"/>
+          </a:xfrm>
+          <a:prstGeom prst="rect">
+            <a:avLst/>
+          </a:prstGeom>
+          <a:solidFill>
+            <a:srgbClr val="E8F0F8"/>
+          </a:solidFill>
+          <a:ln>
+            <a:noFill/>
+          </a:ln>
+          <a:effectLst/>
+        </p:spPr>
+        <p:style>
+          <a:lnRef idx="1">
+            <a:schemeClr val="accent1"/>
+          </a:lnRef>
+          <a:fillRef idx="3">
+            <a:schemeClr val="accent1"/>
+          </a:fillRef>
+          <a:effectRef idx="2">
+            <a:schemeClr val="accent1"/>
+          </a:effectRef>
+          <a:fontRef idx="minor">
+            <a:schemeClr val="lt1"/>
+          </a:fontRef>
+        </p:style>
+        <p:txBody>
+          <a:bodyPr rtlCol="0" anchor="ctr"/>
+          <a:lstStyle/>
+          <a:p>
+            <a:pPr algn="ctr"/>
+          </a:p>
+        </p:txBody>
+      </p:sp>
+      <p:sp>
+        <p:nvSpPr>
+          <p:cNvPr id="23" name="Rectangle 22"/>
+          <p:cNvSpPr/>
+          <p:nvPr/>
+        </p:nvSpPr>
+        <p:spPr>
+          <a:xfrm>
+            <a:off x="502920" y="4718304"/>
+            <a:ext cx="109728" cy="1024128"/>
+          </a:xfrm>
+          <a:prstGeom prst="rect">
+            <a:avLst/>
+          </a:prstGeom>
+          <a:solidFill>
+            <a:srgbClr val="0078D4"/>
+          </a:solidFill>
+          <a:ln>
+            <a:noFill/>
+          </a:ln>
+          <a:effectLst/>
+        </p:spPr>
+        <p:style>
+          <a:lnRef idx="1">
+            <a:schemeClr val="accent1"/>
+          </a:lnRef>
+          <a:fillRef idx="3">
+            <a:schemeClr val="accent1"/>
+          </a:fillRef>
+          <a:effectRef idx="2">
+            <a:schemeClr val="accent1"/>
+          </a:effectRef>
+          <a:fontRef idx="minor">
+            <a:schemeClr val="lt1"/>
+          </a:fontRef>
+        </p:style>
+        <p:txBody>
+          <a:bodyPr rtlCol="0" anchor="ctr"/>
+          <a:lstStyle/>
+          <a:p>
+            <a:pPr algn="ctr"/>
+          </a:p>
+        </p:txBody>
+      </p:sp>
+      <p:sp>
+        <p:nvSpPr>
+          <p:cNvPr id="24" name="TextBox 23"/>
+          <p:cNvSpPr txBox="1"/>
+          <p:nvPr/>
+        </p:nvSpPr>
+        <p:spPr>
+          <a:xfrm>
+            <a:off x="777240" y="4773168"/>
+            <a:ext cx="6446520" cy="292608"/>
+          </a:xfrm>
+          <a:prstGeom prst="rect">
+            <a:avLst/>
+          </a:prstGeom>
+          <a:noFill/>
+        </p:spPr>
+        <p:txBody>
+          <a:bodyPr wrap="square" anchor="t" lIns="73152" rIns="73152" tIns="36576" bIns="36576">
+            <a:spAutoFit/>
+          </a:bodyPr>
+          <a:lstStyle/>
+          <a:p>
+            <a:pPr algn="l"/>
+            <a:r>
+              <a:rPr sz="1600" b="1">
+                <a:solidFill>
+                  <a:srgbClr val="0C294B"/>
+                </a:solidFill>
+              </a:rPr>
+              <a:t>PLDT (Philippines)</a:t>
+            </a:r>
+          </a:p>
+        </p:txBody>
+      </p:sp>
+      <p:sp>
+        <p:nvSpPr>
+          <p:cNvPr id="25" name="TextBox 24"/>
+          <p:cNvSpPr txBox="1"/>
+          <p:nvPr/>
+        </p:nvSpPr>
+        <p:spPr>
+          <a:xfrm>
+            <a:off x="777240" y="5047488"/>
+            <a:ext cx="6446520" cy="237744"/>
+          </a:xfrm>
+          <a:prstGeom prst="rect">
+            <a:avLst/>
+          </a:prstGeom>
+          <a:noFill/>
+        </p:spPr>
+        <p:txBody>
+          <a:bodyPr wrap="square" anchor="t" lIns="73152" rIns="73152" tIns="36576" bIns="36576">
+            <a:spAutoFit/>
+          </a:bodyPr>
+          <a:lstStyle/>
+          <a:p>
+            <a:pPr algn="l"/>
+            <a:r>
+              <a:rPr sz="1200" b="0">
+                <a:solidFill>
+                  <a:srgbClr val="5F5A6B"/>
+                </a:solidFill>
+              </a:rPr>
+              <a:t>CEP Unified Case Management — agents use Dynamics 365</a:t>
+            </a:r>
+          </a:p>
+        </p:txBody>
+      </p:sp>
+      <p:sp>
+        <p:nvSpPr>
+          <p:cNvPr id="26" name="TextBox 25"/>
+          <p:cNvSpPr txBox="1"/>
+          <p:nvPr/>
+        </p:nvSpPr>
+        <p:spPr>
+          <a:xfrm>
+            <a:off x="777240" y="5321808"/>
+            <a:ext cx="6446520" cy="347472"/>
+          </a:xfrm>
+          <a:prstGeom prst="rect">
+            <a:avLst/>
+          </a:prstGeom>
+          <a:noFill/>
+        </p:spPr>
+        <p:txBody>
+          <a:bodyPr wrap="square" anchor="t" lIns="73152" rIns="73152" tIns="36576" bIns="36576">
+            <a:spAutoFit/>
+          </a:bodyPr>
+          <a:lstStyle/>
+          <a:p>
+            <a:pPr algn="l"/>
+            <a:r>
+              <a:rPr sz="1300" b="1">
+                <a:solidFill>
+                  <a:srgbClr val="26222E"/>
+                </a:solidFill>
+              </a:rPr>
+              <a:t>IDC: 6 weeks; 48% faster L1; +27 NPS. Care, not catalog publish.</a:t>
+            </a:r>
+          </a:p>
+        </p:txBody>
+      </p:sp>
+      <p:sp>
+        <p:nvSpPr>
+          <p:cNvPr id="27" name="Rectangle 26"/>
+          <p:cNvSpPr/>
+          <p:nvPr/>
+        </p:nvSpPr>
+        <p:spPr>
+          <a:xfrm>
+            <a:off x="7970676" y="1335024"/>
+            <a:ext cx="3306767" cy="4645152"/>
           </a:xfrm>
           <a:prstGeom prst="rect">
             <a:avLst/>
@@ -9927,7 +10151,7 @@
       </p:sp>
       <p:pic>
         <p:nvPicPr>
-          <p:cNvPr id="22" name="Picture 21" descr="10_sprint_results.png"/>
+          <p:cNvPr id="28" name="Picture 27" descr="10_sprint_results.png"/>
           <p:cNvPicPr>
             <a:picLocks noChangeAspect="1"/>
           </p:cNvPicPr>
@@ -9941,8 +10165,8 @@
         </p:blipFill>
         <p:spPr>
           <a:xfrm>
-            <a:off x="7958748" y="1280160"/>
-            <a:ext cx="3330623" cy="4709160"/>
+            <a:off x="8007252" y="1371600"/>
+            <a:ext cx="3233615" cy="4572000"/>
           </a:xfrm>
           <a:prstGeom prst="rect">
             <a:avLst/>
@@ -9951,13 +10175,13 @@
       </p:pic>
       <p:sp>
         <p:nvSpPr>
-          <p:cNvPr id="23" name="TextBox 22"/>
+          <p:cNvPr id="29" name="TextBox 28"/>
           <p:cNvSpPr txBox="1"/>
           <p:nvPr/>
         </p:nvSpPr>
         <p:spPr>
           <a:xfrm>
-            <a:off x="7543800" y="6044184"/>
+            <a:off x="7543800" y="5998464"/>
             <a:ext cx="4160520" cy="411480"/>
           </a:xfrm>
           <a:prstGeom prst="rect">
@@ -9979,40 +10203,6 @@
                 </a:solidFill>
               </a:rPr>
               <a:t>Source: TM Forum, Sprint case study</a:t>
-            </a:r>
-          </a:p>
-        </p:txBody>
-      </p:sp>
-      <p:sp>
-        <p:nvSpPr>
-          <p:cNvPr id="24" name="TextBox 23"/>
-          <p:cNvSpPr txBox="1"/>
-          <p:nvPr/>
-        </p:nvSpPr>
-        <p:spPr>
-          <a:xfrm>
-            <a:off x="502920" y="5120640"/>
-            <a:ext cx="6858000" cy="1005840"/>
-          </a:xfrm>
-          <a:prstGeom prst="rect">
-            <a:avLst/>
-          </a:prstGeom>
-          <a:noFill/>
-        </p:spPr>
-        <p:txBody>
-          <a:bodyPr wrap="square" anchor="t" lIns="73152" rIns="73152" tIns="36576" bIns="36576">
-            <a:spAutoFit/>
-          </a:bodyPr>
-          <a:lstStyle/>
-          <a:p>
-            <a:pPr algn="l"/>
-            <a:r>
-              <a:rPr sz="1300" b="0">
-                <a:solidFill>
-                  <a:srgbClr val="5F5A6B"/>
-                </a:solidFill>
-              </a:rPr>
-              <a:t>Mtel (A1 Bulgaria), earlier Amdocs Master Enterprise Catalog: &gt;80% faster TTM; complex offers idea-to-production in under three days (CTO quote).</a:t>
             </a:r>
           </a:p>
         </p:txBody>
@@ -10142,7 +10332,7 @@
                   <a:srgbClr val="5F5A6B"/>
                 </a:solidFill>
               </a:rPr>
-              <a:t>PLC study  |  Amdocs CatalogONE: from idea to Dynamics 365</a:t>
+              <a:t>PLC study  |  Amdocs CatalogONE: from idea to CRM</a:t>
             </a:r>
           </a:p>
         </p:txBody>
@@ -10210,7 +10400,7 @@
               <a:buChar char="•"/>
             </a:pPr>
             <a:r>
-              <a:rPr b="1" sz="1600">
+              <a:rPr b="1" sz="1500">
                 <a:solidFill>
                   <a:srgbClr val="0C294B"/>
                 </a:solidFill>
@@ -10218,7 +10408,7 @@
               <a:t>Idea to Active </a:t>
             </a:r>
             <a:r>
-              <a:rPr sz="1600">
+              <a:rPr sz="1500">
                 <a:solidFill>
                   <a:srgbClr val="26222E"/>
                 </a:solidFill>
@@ -10234,20 +10424,20 @@
               <a:buChar char="•"/>
             </a:pPr>
             <a:r>
-              <a:rPr b="1" sz="1600">
+              <a:rPr b="1" sz="1500">
                 <a:solidFill>
                   <a:srgbClr val="0C294B"/>
                 </a:solidFill>
               </a:rPr>
-              <a:t>Active to Dynamics 365 </a:t>
-            </a:r>
-            <a:r>
-              <a:rPr sz="1600">
+              <a:t>CatalogONE publishes </a:t>
+            </a:r>
+            <a:r>
+              <a:rPr sz="1500">
                 <a:solidFill>
                   <a:srgbClr val="26222E"/>
                 </a:solidFill>
               </a:rPr>
-              <a:t>through Centralized publish, Kafka and TMF620. The catalog stays the single source of truth.</a:t>
+              <a:t>to consuming applications and "the customer's CRM" via Centralized, Kafka and TMF620.</a:t>
             </a:r>
           </a:p>
           <a:p>
@@ -10258,20 +10448,20 @@
               <a:buChar char="•"/>
             </a:pPr>
             <a:r>
-              <a:rPr b="1" sz="1600">
+              <a:rPr b="1" sz="1500">
                 <a:solidFill>
                   <a:srgbClr val="0C294B"/>
                 </a:solidFill>
               </a:rPr>
-              <a:t>CRM is not replaced. </a:t>
-            </a:r>
-            <a:r>
-              <a:rPr sz="1600">
+              <a:t>Dynamics 365 is named on CEP, </a:t>
+            </a:r>
+            <a:r>
+              <a:rPr sz="1500">
                 <a:solidFill>
                   <a:srgbClr val="26222E"/>
                 </a:solidFill>
               </a:rPr>
-              <a:t>Sales, quotes and orders stay in Dynamics.</a:t>
+              <a:t>as Sales and Customer Service next to Catalog — not on the CatalogONE datasheet as a connector. PLDT is live on CEP care.</a:t>
             </a:r>
           </a:p>
           <a:p>
@@ -10282,20 +10472,20 @@
               <a:buChar char="•"/>
             </a:pPr>
             <a:r>
-              <a:rPr b="1" sz="1600">
+              <a:rPr b="1" sz="1500">
                 <a:solidFill>
                   <a:srgbClr val="0C294B"/>
                 </a:solidFill>
               </a:rPr>
-              <a:t>Rules and prices </a:t>
-            </a:r>
-            <a:r>
-              <a:rPr sz="1600">
+              <a:t>Two paths: </a:t>
+            </a:r>
+            <a:r>
+              <a:rPr sz="1500">
                 <a:solidFill>
                   <a:srgbClr val="26222E"/>
                 </a:solidFill>
               </a:rPr>
-              <a:t>are enforced from the catalog, not re-typed.</a:t>
+              <a:t>buy CEP, or keep Dynamics and integrate via TMF620. CRM is not replaced.</a:t>
             </a:r>
           </a:p>
           <a:p>
@@ -10306,7 +10496,7 @@
               <a:buChar char="•"/>
             </a:pPr>
             <a:r>
-              <a:rPr b="1" sz="1600">
+              <a:rPr b="1" sz="1500">
                 <a:solidFill>
                   <a:srgbClr val="0C294B"/>
                 </a:solidFill>
@@ -10314,7 +10504,7 @@
               <a:t>Changes are versioned, </a:t>
             </a:r>
             <a:r>
-              <a:rPr sz="1600">
+              <a:rPr sz="1500">
                 <a:solidFill>
                   <a:srgbClr val="26222E"/>
                 </a:solidFill>
@@ -10330,20 +10520,20 @@
               <a:buChar char="•"/>
             </a:pPr>
             <a:r>
-              <a:rPr b="1" sz="1600">
+              <a:rPr b="1" sz="1500">
                 <a:solidFill>
                   <a:srgbClr val="0C294B"/>
                 </a:solidFill>
               </a:rPr>
-              <a:t>Proven </a:t>
-            </a:r>
-            <a:r>
-              <a:rPr sz="1600">
+              <a:t>Proven CatalogONE </a:t>
+            </a:r>
+            <a:r>
+              <a:rPr sz="1500">
                 <a:solidFill>
                   <a:srgbClr val="26222E"/>
                 </a:solidFill>
               </a:rPr>
-              <a:t>at a European quad-play, Sprint / T-Mobile and KT.</a:t>
+              <a:t>at a European quad-play, Sprint / T-Mobile and KT. CEP + Dynamics 365 is live at PLDT for case management.</a:t>
             </a:r>
           </a:p>
         </p:txBody>
@@ -10549,7 +10739,7 @@
                   <a:srgbClr val="26222E"/>
                 </a:solidFill>
               </a:rPr>
-              <a:t>7. TM Forum Sprint / T-Mobile case study</a:t>
+              <a:t>7. IDC PLDT case study (CEP Unified Case Management, 2026)</a:t>
             </a:r>
           </a:p>
           <a:p>
@@ -10564,7 +10754,7 @@
                   <a:srgbClr val="26222E"/>
                 </a:solidFill>
               </a:rPr>
-              <a:t>8. Amdocs KT CatalogONE press release (Nov 2020)</a:t>
+              <a:t>8. TM Forum Sprint / T-Mobile case study</a:t>
             </a:r>
           </a:p>
           <a:p>
@@ -10579,7 +10769,7 @@
                   <a:srgbClr val="26222E"/>
                 </a:solidFill>
               </a:rPr>
-              <a:t>9. TM Forum Open API conformance (Amdocs TMF620)</a:t>
+              <a:t>9. Amdocs KT CatalogONE press release (Nov 2020)</a:t>
             </a:r>
           </a:p>
           <a:p>
@@ -10594,7 +10784,22 @@
                   <a:srgbClr val="26222E"/>
                 </a:solidFill>
               </a:rPr>
-              <a:t>10. Microsoft Learn: Dynamics 365 product catalog</a:t>
+              <a:t>10. TM Forum Open API conformance (Amdocs TMF620)</a:t>
+            </a:r>
+          </a:p>
+          <a:p>
+            <a:pPr algn="l">
+              <a:spcAft>
+                <a:spcPts val="660"/>
+              </a:spcAft>
+            </a:pPr>
+            <a:r>
+              <a:rPr sz="1200" b="0">
+                <a:solidFill>
+                  <a:srgbClr val="26222E"/>
+                </a:solidFill>
+              </a:rPr>
+              <a:t>11. Microsoft Learn: Dynamics 365 product catalog</a:t>
             </a:r>
           </a:p>
         </p:txBody>
@@ -10724,7 +10929,7 @@
                   <a:srgbClr val="5F5A6B"/>
                 </a:solidFill>
               </a:rPr>
-              <a:t>PLC study  |  Amdocs CatalogONE: from idea to Dynamics 365</a:t>
+              <a:t>PLC study  |  Amdocs CatalogONE: from idea to CRM</a:t>
             </a:r>
           </a:p>
         </p:txBody>
@@ -10904,7 +11109,7 @@
                   <a:srgbClr val="5F5A6B"/>
                 </a:solidFill>
               </a:rPr>
-              <a:t>Catalog only; CRM stays Dynamics</a:t>
+              <a:t>Catalog only; CRM is not replaced</a:t>
             </a:r>
           </a:p>
         </p:txBody>
@@ -11454,7 +11659,7 @@
                   <a:srgbClr val="26222E"/>
                 </a:solidFill>
               </a:rPr>
-              <a:t>Publish to Dynamics 365</a:t>
+              <a:t>How catalog reaches CRM</a:t>
             </a:r>
           </a:p>
         </p:txBody>
@@ -11488,7 +11693,7 @@
                   <a:srgbClr val="5F5A6B"/>
                 </a:solidFill>
               </a:rPr>
-              <a:t>How the product reaches the salesperson</a:t>
+              <a:t>CatalogONE vs CEP vs Dynamics</a:t>
             </a:r>
           </a:p>
         </p:txBody>
@@ -11730,7 +11935,7 @@
                   <a:srgbClr val="0C294B"/>
                 </a:solidFill>
               </a:rPr>
-              <a:t>Why this PLC: catalog only, CRM stays Dynamics</a:t>
+              <a:t>Why this PLC: catalog only. CRM is not replaced.</a:t>
             </a:r>
           </a:p>
         </p:txBody>
@@ -11743,8 +11948,8 @@
         </p:nvSpPr>
         <p:spPr>
           <a:xfrm>
-            <a:off x="548640" y="6446520"/>
-            <a:ext cx="8686800" cy="274320"/>
+            <a:off x="548640" y="914400"/>
+            <a:ext cx="10972800" cy="411480"/>
           </a:xfrm>
           <a:prstGeom prst="rect">
             <a:avLst/>
@@ -11759,12 +11964,12 @@
           <a:p>
             <a:pPr algn="l"/>
             <a:r>
-              <a:rPr sz="1000" b="0">
+              <a:rPr sz="1500" b="0">
                 <a:solidFill>
                   <a:srgbClr val="5F5A6B"/>
                 </a:solidFill>
               </a:rPr>
-              <a:t>PLC study  |  Amdocs CatalogONE: from idea to Dynamics 365</a:t>
+              <a:t>Two facts, kept separate: CatalogONE publishes to CRM. CEP names Dynamics 365.</a:t>
             </a:r>
           </a:p>
         </p:txBody>
@@ -11777,8 +11982,8 @@
         </p:nvSpPr>
         <p:spPr>
           <a:xfrm>
-            <a:off x="10698480" y="6446520"/>
-            <a:ext cx="914400" cy="274320"/>
+            <a:off x="548640" y="6446520"/>
+            <a:ext cx="8686800" cy="274320"/>
           </a:xfrm>
           <a:prstGeom prst="rect">
             <a:avLst/>
@@ -11791,6 +11996,40 @@
           </a:bodyPr>
           <a:lstStyle/>
           <a:p>
+            <a:pPr algn="l"/>
+            <a:r>
+              <a:rPr sz="1000" b="0">
+                <a:solidFill>
+                  <a:srgbClr val="5F5A6B"/>
+                </a:solidFill>
+              </a:rPr>
+              <a:t>PLC study  |  Amdocs CatalogONE: from idea to CRM</a:t>
+            </a:r>
+          </a:p>
+        </p:txBody>
+      </p:sp>
+      <p:sp>
+        <p:nvSpPr>
+          <p:cNvPr id="6" name="TextBox 5"/>
+          <p:cNvSpPr txBox="1"/>
+          <p:nvPr/>
+        </p:nvSpPr>
+        <p:spPr>
+          <a:xfrm>
+            <a:off x="10698480" y="6446520"/>
+            <a:ext cx="914400" cy="274320"/>
+          </a:xfrm>
+          <a:prstGeom prst="rect">
+            <a:avLst/>
+          </a:prstGeom>
+          <a:noFill/>
+        </p:spPr>
+        <p:txBody>
+          <a:bodyPr wrap="square" anchor="t" lIns="73152" rIns="73152" tIns="36576" bIns="36576">
+            <a:spAutoFit/>
+          </a:bodyPr>
+          <a:lstStyle/>
+          <a:p>
             <a:pPr algn="r"/>
             <a:r>
               <a:rPr sz="1000" b="0">
@@ -11805,14 +12044,14 @@
       </p:sp>
       <p:sp>
         <p:nvSpPr>
-          <p:cNvPr id="6" name="Rectangle 5"/>
+          <p:cNvPr id="7" name="Rectangle 6"/>
           <p:cNvSpPr/>
           <p:nvPr/>
         </p:nvSpPr>
         <p:spPr>
           <a:xfrm>
-            <a:off x="548640" y="1371600"/>
-            <a:ext cx="3474720" cy="2194560"/>
+            <a:off x="548640" y="1463040"/>
+            <a:ext cx="3474720" cy="2103120"/>
           </a:xfrm>
           <a:prstGeom prst="rect">
             <a:avLst/>
@@ -11849,13 +12088,637 @@
       </p:sp>
       <p:sp>
         <p:nvSpPr>
-          <p:cNvPr id="7" name="Rectangle 6"/>
+          <p:cNvPr id="8" name="Rectangle 7"/>
           <p:cNvSpPr/>
           <p:nvPr/>
         </p:nvSpPr>
         <p:spPr>
           <a:xfrm>
-            <a:off x="548640" y="1371600"/>
+            <a:off x="548640" y="1463040"/>
+            <a:ext cx="3474720" cy="91440"/>
+          </a:xfrm>
+          <a:prstGeom prst="rect">
+            <a:avLst/>
+          </a:prstGeom>
+          <a:solidFill>
+            <a:srgbClr val="0C294B"/>
+          </a:solidFill>
+          <a:ln>
+            <a:noFill/>
+          </a:ln>
+          <a:effectLst/>
+        </p:spPr>
+        <p:style>
+          <a:lnRef idx="1">
+            <a:schemeClr val="accent1"/>
+          </a:lnRef>
+          <a:fillRef idx="3">
+            <a:schemeClr val="accent1"/>
+          </a:fillRef>
+          <a:effectRef idx="2">
+            <a:schemeClr val="accent1"/>
+          </a:effectRef>
+          <a:fontRef idx="minor">
+            <a:schemeClr val="lt1"/>
+          </a:fontRef>
+        </p:style>
+        <p:txBody>
+          <a:bodyPr rtlCol="0" anchor="ctr"/>
+          <a:lstStyle/>
+          <a:p>
+            <a:pPr algn="ctr"/>
+          </a:p>
+        </p:txBody>
+      </p:sp>
+      <p:sp>
+        <p:nvSpPr>
+          <p:cNvPr id="9" name="TextBox 8"/>
+          <p:cNvSpPr txBox="1"/>
+          <p:nvPr/>
+        </p:nvSpPr>
+        <p:spPr>
+          <a:xfrm>
+            <a:off x="685800" y="1691640"/>
+            <a:ext cx="3200400" cy="457200"/>
+          </a:xfrm>
+          <a:prstGeom prst="rect">
+            <a:avLst/>
+          </a:prstGeom>
+          <a:noFill/>
+        </p:spPr>
+        <p:txBody>
+          <a:bodyPr wrap="square" anchor="t" lIns="73152" rIns="73152" tIns="36576" bIns="36576">
+            <a:spAutoFit/>
+          </a:bodyPr>
+          <a:lstStyle/>
+          <a:p>
+            <a:pPr algn="l"/>
+            <a:r>
+              <a:rPr sz="1700" b="1">
+                <a:solidFill>
+                  <a:srgbClr val="0C294B"/>
+                </a:solidFill>
+              </a:rPr>
+              <a:t>Catalog, not CRM</a:t>
+            </a:r>
+          </a:p>
+        </p:txBody>
+      </p:sp>
+      <p:sp>
+        <p:nvSpPr>
+          <p:cNvPr id="10" name="TextBox 9"/>
+          <p:cNvSpPr txBox="1"/>
+          <p:nvPr/>
+        </p:nvSpPr>
+        <p:spPr>
+          <a:xfrm>
+            <a:off x="685800" y="2194560"/>
+            <a:ext cx="3200400" cy="1234440"/>
+          </a:xfrm>
+          <a:prstGeom prst="rect">
+            <a:avLst/>
+          </a:prstGeom>
+          <a:noFill/>
+        </p:spPr>
+        <p:txBody>
+          <a:bodyPr wrap="square" anchor="t" lIns="73152" rIns="73152" tIns="36576" bIns="36576">
+            <a:spAutoFit/>
+          </a:bodyPr>
+          <a:lstStyle/>
+          <a:p>
+            <a:pPr algn="l"/>
+            <a:r>
+              <a:rPr sz="1300" b="0">
+                <a:solidFill>
+                  <a:srgbClr val="26222E"/>
+                </a:solidFill>
+              </a:rPr>
+              <a:t>CatalogONE owns products, prices, rules and approvals. It publishes to consuming apps and "the customer's CRM".</a:t>
+            </a:r>
+          </a:p>
+        </p:txBody>
+      </p:sp>
+      <p:sp>
+        <p:nvSpPr>
+          <p:cNvPr id="11" name="Rectangle 10"/>
+          <p:cNvSpPr/>
+          <p:nvPr/>
+        </p:nvSpPr>
+        <p:spPr>
+          <a:xfrm>
+            <a:off x="4297679" y="1463040"/>
+            <a:ext cx="3474720" cy="2103120"/>
+          </a:xfrm>
+          <a:prstGeom prst="rect">
+            <a:avLst/>
+          </a:prstGeom>
+          <a:solidFill>
+            <a:srgbClr val="E8F0F8"/>
+          </a:solidFill>
+          <a:ln>
+            <a:noFill/>
+          </a:ln>
+          <a:effectLst/>
+        </p:spPr>
+        <p:style>
+          <a:lnRef idx="1">
+            <a:schemeClr val="accent1"/>
+          </a:lnRef>
+          <a:fillRef idx="3">
+            <a:schemeClr val="accent1"/>
+          </a:fillRef>
+          <a:effectRef idx="2">
+            <a:schemeClr val="accent1"/>
+          </a:effectRef>
+          <a:fontRef idx="minor">
+            <a:schemeClr val="lt1"/>
+          </a:fontRef>
+        </p:style>
+        <p:txBody>
+          <a:bodyPr rtlCol="0" anchor="ctr"/>
+          <a:lstStyle/>
+          <a:p>
+            <a:pPr algn="ctr"/>
+          </a:p>
+        </p:txBody>
+      </p:sp>
+      <p:sp>
+        <p:nvSpPr>
+          <p:cNvPr id="12" name="Rectangle 11"/>
+          <p:cNvSpPr/>
+          <p:nvPr/>
+        </p:nvSpPr>
+        <p:spPr>
+          <a:xfrm>
+            <a:off x="4297679" y="1463040"/>
+            <a:ext cx="3474720" cy="91440"/>
+          </a:xfrm>
+          <a:prstGeom prst="rect">
+            <a:avLst/>
+          </a:prstGeom>
+          <a:solidFill>
+            <a:srgbClr val="0C294B"/>
+          </a:solidFill>
+          <a:ln>
+            <a:noFill/>
+          </a:ln>
+          <a:effectLst/>
+        </p:spPr>
+        <p:style>
+          <a:lnRef idx="1">
+            <a:schemeClr val="accent1"/>
+          </a:lnRef>
+          <a:fillRef idx="3">
+            <a:schemeClr val="accent1"/>
+          </a:fillRef>
+          <a:effectRef idx="2">
+            <a:schemeClr val="accent1"/>
+          </a:effectRef>
+          <a:fontRef idx="minor">
+            <a:schemeClr val="lt1"/>
+          </a:fontRef>
+        </p:style>
+        <p:txBody>
+          <a:bodyPr rtlCol="0" anchor="ctr"/>
+          <a:lstStyle/>
+          <a:p>
+            <a:pPr algn="ctr"/>
+          </a:p>
+        </p:txBody>
+      </p:sp>
+      <p:sp>
+        <p:nvSpPr>
+          <p:cNvPr id="13" name="TextBox 12"/>
+          <p:cNvSpPr txBox="1"/>
+          <p:nvPr/>
+        </p:nvSpPr>
+        <p:spPr>
+          <a:xfrm>
+            <a:off x="4434839" y="1691640"/>
+            <a:ext cx="3200400" cy="457200"/>
+          </a:xfrm>
+          <a:prstGeom prst="rect">
+            <a:avLst/>
+          </a:prstGeom>
+          <a:noFill/>
+        </p:spPr>
+        <p:txBody>
+          <a:bodyPr wrap="square" anchor="t" lIns="73152" rIns="73152" tIns="36576" bIns="36576">
+            <a:spAutoFit/>
+          </a:bodyPr>
+          <a:lstStyle/>
+          <a:p>
+            <a:pPr algn="l"/>
+            <a:r>
+              <a:rPr sz="1700" b="1">
+                <a:solidFill>
+                  <a:srgbClr val="0C294B"/>
+                </a:solidFill>
+              </a:rPr>
+              <a:t>One source of truth</a:t>
+            </a:r>
+          </a:p>
+        </p:txBody>
+      </p:sp>
+      <p:sp>
+        <p:nvSpPr>
+          <p:cNvPr id="14" name="TextBox 13"/>
+          <p:cNvSpPr txBox="1"/>
+          <p:nvPr/>
+        </p:nvSpPr>
+        <p:spPr>
+          <a:xfrm>
+            <a:off x="4434839" y="2194560"/>
+            <a:ext cx="3200400" cy="1234440"/>
+          </a:xfrm>
+          <a:prstGeom prst="rect">
+            <a:avLst/>
+          </a:prstGeom>
+          <a:noFill/>
+        </p:spPr>
+        <p:txBody>
+          <a:bodyPr wrap="square" anchor="t" lIns="73152" rIns="73152" tIns="36576" bIns="36576">
+            <a:spAutoFit/>
+          </a:bodyPr>
+          <a:lstStyle/>
+          <a:p>
+            <a:pPr algn="l"/>
+            <a:r>
+              <a:rPr sz="1300" b="0">
+                <a:solidFill>
+                  <a:srgbClr val="26222E"/>
+                </a:solidFill>
+              </a:rPr>
+              <a:t>Commercial and technical definitions live once. CRM, ordering and billing consume them.</a:t>
+            </a:r>
+          </a:p>
+        </p:txBody>
+      </p:sp>
+      <p:sp>
+        <p:nvSpPr>
+          <p:cNvPr id="15" name="Rectangle 14"/>
+          <p:cNvSpPr/>
+          <p:nvPr/>
+        </p:nvSpPr>
+        <p:spPr>
+          <a:xfrm>
+            <a:off x="8046719" y="1463040"/>
+            <a:ext cx="3474720" cy="2103120"/>
+          </a:xfrm>
+          <a:prstGeom prst="rect">
+            <a:avLst/>
+          </a:prstGeom>
+          <a:solidFill>
+            <a:srgbClr val="E8F0F8"/>
+          </a:solidFill>
+          <a:ln>
+            <a:noFill/>
+          </a:ln>
+          <a:effectLst/>
+        </p:spPr>
+        <p:style>
+          <a:lnRef idx="1">
+            <a:schemeClr val="accent1"/>
+          </a:lnRef>
+          <a:fillRef idx="3">
+            <a:schemeClr val="accent1"/>
+          </a:fillRef>
+          <a:effectRef idx="2">
+            <a:schemeClr val="accent1"/>
+          </a:effectRef>
+          <a:fontRef idx="minor">
+            <a:schemeClr val="lt1"/>
+          </a:fontRef>
+        </p:style>
+        <p:txBody>
+          <a:bodyPr rtlCol="0" anchor="ctr"/>
+          <a:lstStyle/>
+          <a:p>
+            <a:pPr algn="ctr"/>
+          </a:p>
+        </p:txBody>
+      </p:sp>
+      <p:sp>
+        <p:nvSpPr>
+          <p:cNvPr id="16" name="Rectangle 15"/>
+          <p:cNvSpPr/>
+          <p:nvPr/>
+        </p:nvSpPr>
+        <p:spPr>
+          <a:xfrm>
+            <a:off x="8046719" y="1463040"/>
+            <a:ext cx="3474720" cy="91440"/>
+          </a:xfrm>
+          <a:prstGeom prst="rect">
+            <a:avLst/>
+          </a:prstGeom>
+          <a:solidFill>
+            <a:srgbClr val="0C294B"/>
+          </a:solidFill>
+          <a:ln>
+            <a:noFill/>
+          </a:ln>
+          <a:effectLst/>
+        </p:spPr>
+        <p:style>
+          <a:lnRef idx="1">
+            <a:schemeClr val="accent1"/>
+          </a:lnRef>
+          <a:fillRef idx="3">
+            <a:schemeClr val="accent1"/>
+          </a:fillRef>
+          <a:effectRef idx="2">
+            <a:schemeClr val="accent1"/>
+          </a:effectRef>
+          <a:fontRef idx="minor">
+            <a:schemeClr val="lt1"/>
+          </a:fontRef>
+        </p:style>
+        <p:txBody>
+          <a:bodyPr rtlCol="0" anchor="ctr"/>
+          <a:lstStyle/>
+          <a:p>
+            <a:pPr algn="ctr"/>
+          </a:p>
+        </p:txBody>
+      </p:sp>
+      <p:sp>
+        <p:nvSpPr>
+          <p:cNvPr id="17" name="TextBox 16"/>
+          <p:cNvSpPr txBox="1"/>
+          <p:nvPr/>
+        </p:nvSpPr>
+        <p:spPr>
+          <a:xfrm>
+            <a:off x="8183879" y="1691640"/>
+            <a:ext cx="3200400" cy="457200"/>
+          </a:xfrm>
+          <a:prstGeom prst="rect">
+            <a:avLst/>
+          </a:prstGeom>
+          <a:noFill/>
+        </p:spPr>
+        <p:txBody>
+          <a:bodyPr wrap="square" anchor="t" lIns="73152" rIns="73152" tIns="36576" bIns="36576">
+            <a:spAutoFit/>
+          </a:bodyPr>
+          <a:lstStyle/>
+          <a:p>
+            <a:pPr algn="l"/>
+            <a:r>
+              <a:rPr sz="1700" b="1">
+                <a:solidFill>
+                  <a:srgbClr val="0C294B"/>
+                </a:solidFill>
+              </a:rPr>
+              <a:t>A governed journey</a:t>
+            </a:r>
+          </a:p>
+        </p:txBody>
+      </p:sp>
+      <p:sp>
+        <p:nvSpPr>
+          <p:cNvPr id="18" name="TextBox 17"/>
+          <p:cNvSpPr txBox="1"/>
+          <p:nvPr/>
+        </p:nvSpPr>
+        <p:spPr>
+          <a:xfrm>
+            <a:off x="8183879" y="2194560"/>
+            <a:ext cx="3200400" cy="1234440"/>
+          </a:xfrm>
+          <a:prstGeom prst="rect">
+            <a:avLst/>
+          </a:prstGeom>
+          <a:noFill/>
+        </p:spPr>
+        <p:txBody>
+          <a:bodyPr wrap="square" anchor="t" lIns="73152" rIns="73152" tIns="36576" bIns="36576">
+            <a:spAutoFit/>
+          </a:bodyPr>
+          <a:lstStyle/>
+          <a:p>
+            <a:pPr algn="l"/>
+            <a:r>
+              <a:rPr sz="1300" b="0">
+                <a:solidFill>
+                  <a:srgbClr val="26222E"/>
+                </a:solidFill>
+              </a:rPr>
+              <a:t>Ideation to end-of-life, with workflow, approvals, simulations and versioned change.</a:t>
+            </a:r>
+          </a:p>
+        </p:txBody>
+      </p:sp>
+      <p:sp>
+        <p:nvSpPr>
+          <p:cNvPr id="19" name="Rectangle 18"/>
+          <p:cNvSpPr/>
+          <p:nvPr/>
+        </p:nvSpPr>
+        <p:spPr>
+          <a:xfrm>
+            <a:off x="548640" y="3794760"/>
+            <a:ext cx="3474720" cy="2103120"/>
+          </a:xfrm>
+          <a:prstGeom prst="rect">
+            <a:avLst/>
+          </a:prstGeom>
+          <a:solidFill>
+            <a:srgbClr val="E8F0F8"/>
+          </a:solidFill>
+          <a:ln>
+            <a:noFill/>
+          </a:ln>
+          <a:effectLst/>
+        </p:spPr>
+        <p:style>
+          <a:lnRef idx="1">
+            <a:schemeClr val="accent1"/>
+          </a:lnRef>
+          <a:fillRef idx="3">
+            <a:schemeClr val="accent1"/>
+          </a:fillRef>
+          <a:effectRef idx="2">
+            <a:schemeClr val="accent1"/>
+          </a:effectRef>
+          <a:fontRef idx="minor">
+            <a:schemeClr val="lt1"/>
+          </a:fontRef>
+        </p:style>
+        <p:txBody>
+          <a:bodyPr rtlCol="0" anchor="ctr"/>
+          <a:lstStyle/>
+          <a:p>
+            <a:pPr algn="ctr"/>
+          </a:p>
+        </p:txBody>
+      </p:sp>
+      <p:sp>
+        <p:nvSpPr>
+          <p:cNvPr id="20" name="Rectangle 19"/>
+          <p:cNvSpPr/>
+          <p:nvPr/>
+        </p:nvSpPr>
+        <p:spPr>
+          <a:xfrm>
+            <a:off x="548640" y="3794760"/>
+            <a:ext cx="3474720" cy="91440"/>
+          </a:xfrm>
+          <a:prstGeom prst="rect">
+            <a:avLst/>
+          </a:prstGeom>
+          <a:solidFill>
+            <a:srgbClr val="0C294B"/>
+          </a:solidFill>
+          <a:ln>
+            <a:noFill/>
+          </a:ln>
+          <a:effectLst/>
+        </p:spPr>
+        <p:style>
+          <a:lnRef idx="1">
+            <a:schemeClr val="accent1"/>
+          </a:lnRef>
+          <a:fillRef idx="3">
+            <a:schemeClr val="accent1"/>
+          </a:fillRef>
+          <a:effectRef idx="2">
+            <a:schemeClr val="accent1"/>
+          </a:effectRef>
+          <a:fontRef idx="minor">
+            <a:schemeClr val="lt1"/>
+          </a:fontRef>
+        </p:style>
+        <p:txBody>
+          <a:bodyPr rtlCol="0" anchor="ctr"/>
+          <a:lstStyle/>
+          <a:p>
+            <a:pPr algn="ctr"/>
+          </a:p>
+        </p:txBody>
+      </p:sp>
+      <p:sp>
+        <p:nvSpPr>
+          <p:cNvPr id="21" name="TextBox 20"/>
+          <p:cNvSpPr txBox="1"/>
+          <p:nvPr/>
+        </p:nvSpPr>
+        <p:spPr>
+          <a:xfrm>
+            <a:off x="685800" y="4023360"/>
+            <a:ext cx="3200400" cy="457200"/>
+          </a:xfrm>
+          <a:prstGeom prst="rect">
+            <a:avLst/>
+          </a:prstGeom>
+          <a:noFill/>
+        </p:spPr>
+        <p:txBody>
+          <a:bodyPr wrap="square" anchor="t" lIns="73152" rIns="73152" tIns="36576" bIns="36576">
+            <a:spAutoFit/>
+          </a:bodyPr>
+          <a:lstStyle/>
+          <a:p>
+            <a:pPr algn="l"/>
+            <a:r>
+              <a:rPr sz="1700" b="1">
+                <a:solidFill>
+                  <a:srgbClr val="0C294B"/>
+                </a:solidFill>
+              </a:rPr>
+              <a:t>Business users configure</a:t>
+            </a:r>
+          </a:p>
+        </p:txBody>
+      </p:sp>
+      <p:sp>
+        <p:nvSpPr>
+          <p:cNvPr id="22" name="TextBox 21"/>
+          <p:cNvSpPr txBox="1"/>
+          <p:nvPr/>
+        </p:nvSpPr>
+        <p:spPr>
+          <a:xfrm>
+            <a:off x="685800" y="4526280"/>
+            <a:ext cx="3200400" cy="1234440"/>
+          </a:xfrm>
+          <a:prstGeom prst="rect">
+            <a:avLst/>
+          </a:prstGeom>
+          <a:noFill/>
+        </p:spPr>
+        <p:txBody>
+          <a:bodyPr wrap="square" anchor="t" lIns="73152" rIns="73152" tIns="36576" bIns="36576">
+            <a:spAutoFit/>
+          </a:bodyPr>
+          <a:lstStyle/>
+          <a:p>
+            <a:pPr algn="l"/>
+            <a:r>
+              <a:rPr sz="1300" b="0">
+                <a:solidFill>
+                  <a:srgbClr val="26222E"/>
+                </a:solidFill>
+              </a:rPr>
+              <a:t>Role-based UI, templates and building blocks. No code. No deployment overhead.</a:t>
+            </a:r>
+          </a:p>
+        </p:txBody>
+      </p:sp>
+      <p:sp>
+        <p:nvSpPr>
+          <p:cNvPr id="23" name="Rectangle 22"/>
+          <p:cNvSpPr/>
+          <p:nvPr/>
+        </p:nvSpPr>
+        <p:spPr>
+          <a:xfrm>
+            <a:off x="4297679" y="3794760"/>
+            <a:ext cx="3474720" cy="2103120"/>
+          </a:xfrm>
+          <a:prstGeom prst="rect">
+            <a:avLst/>
+          </a:prstGeom>
+          <a:solidFill>
+            <a:srgbClr val="E8F0F8"/>
+          </a:solidFill>
+          <a:ln>
+            <a:noFill/>
+          </a:ln>
+          <a:effectLst/>
+        </p:spPr>
+        <p:style>
+          <a:lnRef idx="1">
+            <a:schemeClr val="accent1"/>
+          </a:lnRef>
+          <a:fillRef idx="3">
+            <a:schemeClr val="accent1"/>
+          </a:fillRef>
+          <a:effectRef idx="2">
+            <a:schemeClr val="accent1"/>
+          </a:effectRef>
+          <a:fontRef idx="minor">
+            <a:schemeClr val="lt1"/>
+          </a:fontRef>
+        </p:style>
+        <p:txBody>
+          <a:bodyPr rtlCol="0" anchor="ctr"/>
+          <a:lstStyle/>
+          <a:p>
+            <a:pPr algn="ctr"/>
+          </a:p>
+        </p:txBody>
+      </p:sp>
+      <p:sp>
+        <p:nvSpPr>
+          <p:cNvPr id="24" name="Rectangle 23"/>
+          <p:cNvSpPr/>
+          <p:nvPr/>
+        </p:nvSpPr>
+        <p:spPr>
+          <a:xfrm>
+            <a:off x="4297679" y="3794760"/>
             <a:ext cx="3474720" cy="91440"/>
           </a:xfrm>
           <a:prstGeom prst="rect">
@@ -11893,14 +12756,14 @@
       </p:sp>
       <p:sp>
         <p:nvSpPr>
-          <p:cNvPr id="8" name="TextBox 7"/>
+          <p:cNvPr id="25" name="TextBox 24"/>
           <p:cNvSpPr txBox="1"/>
           <p:nvPr/>
         </p:nvSpPr>
         <p:spPr>
           <a:xfrm>
-            <a:off x="685800" y="1645920"/>
-            <a:ext cx="3200400" cy="502920"/>
+            <a:off x="4434839" y="4023360"/>
+            <a:ext cx="3200400" cy="457200"/>
           </a:xfrm>
           <a:prstGeom prst="rect">
             <a:avLst/>
@@ -11915,25 +12778,25 @@
           <a:p>
             <a:pPr algn="l"/>
             <a:r>
-              <a:rPr sz="1800" b="1">
+              <a:rPr sz="1700" b="1">
                 <a:solidFill>
                   <a:srgbClr val="0C294B"/>
                 </a:solidFill>
               </a:rPr>
-              <a:t>Catalog, not CRM</a:t>
-            </a:r>
-          </a:p>
-        </p:txBody>
-      </p:sp>
-      <p:sp>
-        <p:nvSpPr>
-          <p:cNvPr id="9" name="TextBox 8"/>
+              <a:t>Publish, do not re-key</a:t>
+            </a:r>
+          </a:p>
+        </p:txBody>
+      </p:sp>
+      <p:sp>
+        <p:nvSpPr>
+          <p:cNvPr id="26" name="TextBox 25"/>
           <p:cNvSpPr txBox="1"/>
           <p:nvPr/>
         </p:nvSpPr>
         <p:spPr>
           <a:xfrm>
-            <a:off x="685800" y="2194560"/>
+            <a:off x="4434839" y="4526280"/>
             <a:ext cx="3200400" cy="1234440"/>
           </a:xfrm>
           <a:prstGeom prst="rect">
@@ -11949,26 +12812,26 @@
           <a:p>
             <a:pPr algn="l"/>
             <a:r>
-              <a:rPr sz="1400" b="0">
+              <a:rPr sz="1300" b="0">
                 <a:solidFill>
                   <a:srgbClr val="26222E"/>
                 </a:solidFill>
               </a:rPr>
-              <a:t>CatalogONE owns products, prices, rules and approvals. Dynamics 365 stays the sales, quote and order front end.</a:t>
-            </a:r>
-          </a:p>
-        </p:txBody>
-      </p:sp>
-      <p:sp>
-        <p:nvSpPr>
-          <p:cNvPr id="10" name="Rectangle 9"/>
+              <a:t>Kafka + TMF620 to consuming applications. Dynamics 365 is named on CEP, not on the CatalogONE datasheet.</a:t>
+            </a:r>
+          </a:p>
+        </p:txBody>
+      </p:sp>
+      <p:sp>
+        <p:nvSpPr>
+          <p:cNvPr id="27" name="Rectangle 26"/>
           <p:cNvSpPr/>
           <p:nvPr/>
         </p:nvSpPr>
         <p:spPr>
           <a:xfrm>
-            <a:off x="4297679" y="1371600"/>
-            <a:ext cx="3474720" cy="2194560"/>
+            <a:off x="8046719" y="3794760"/>
+            <a:ext cx="3474720" cy="2103120"/>
           </a:xfrm>
           <a:prstGeom prst="rect">
             <a:avLst/>
@@ -12005,631 +12868,7 @@
       </p:sp>
       <p:sp>
         <p:nvSpPr>
-          <p:cNvPr id="11" name="Rectangle 10"/>
-          <p:cNvSpPr/>
-          <p:nvPr/>
-        </p:nvSpPr>
-        <p:spPr>
-          <a:xfrm>
-            <a:off x="4297679" y="1371600"/>
-            <a:ext cx="3474720" cy="91440"/>
-          </a:xfrm>
-          <a:prstGeom prst="rect">
-            <a:avLst/>
-          </a:prstGeom>
-          <a:solidFill>
-            <a:srgbClr val="0C294B"/>
-          </a:solidFill>
-          <a:ln>
-            <a:noFill/>
-          </a:ln>
-          <a:effectLst/>
-        </p:spPr>
-        <p:style>
-          <a:lnRef idx="1">
-            <a:schemeClr val="accent1"/>
-          </a:lnRef>
-          <a:fillRef idx="3">
-            <a:schemeClr val="accent1"/>
-          </a:fillRef>
-          <a:effectRef idx="2">
-            <a:schemeClr val="accent1"/>
-          </a:effectRef>
-          <a:fontRef idx="minor">
-            <a:schemeClr val="lt1"/>
-          </a:fontRef>
-        </p:style>
-        <p:txBody>
-          <a:bodyPr rtlCol="0" anchor="ctr"/>
-          <a:lstStyle/>
-          <a:p>
-            <a:pPr algn="ctr"/>
-          </a:p>
-        </p:txBody>
-      </p:sp>
-      <p:sp>
-        <p:nvSpPr>
-          <p:cNvPr id="12" name="TextBox 11"/>
-          <p:cNvSpPr txBox="1"/>
-          <p:nvPr/>
-        </p:nvSpPr>
-        <p:spPr>
-          <a:xfrm>
-            <a:off x="4434839" y="1645920"/>
-            <a:ext cx="3200400" cy="502920"/>
-          </a:xfrm>
-          <a:prstGeom prst="rect">
-            <a:avLst/>
-          </a:prstGeom>
-          <a:noFill/>
-        </p:spPr>
-        <p:txBody>
-          <a:bodyPr wrap="square" anchor="t" lIns="73152" rIns="73152" tIns="36576" bIns="36576">
-            <a:spAutoFit/>
-          </a:bodyPr>
-          <a:lstStyle/>
-          <a:p>
-            <a:pPr algn="l"/>
-            <a:r>
-              <a:rPr sz="1800" b="1">
-                <a:solidFill>
-                  <a:srgbClr val="0C294B"/>
-                </a:solidFill>
-              </a:rPr>
-              <a:t>One source of truth</a:t>
-            </a:r>
-          </a:p>
-        </p:txBody>
-      </p:sp>
-      <p:sp>
-        <p:nvSpPr>
-          <p:cNvPr id="13" name="TextBox 12"/>
-          <p:cNvSpPr txBox="1"/>
-          <p:nvPr/>
-        </p:nvSpPr>
-        <p:spPr>
-          <a:xfrm>
-            <a:off x="4434839" y="2194560"/>
-            <a:ext cx="3200400" cy="1234440"/>
-          </a:xfrm>
-          <a:prstGeom prst="rect">
-            <a:avLst/>
-          </a:prstGeom>
-          <a:noFill/>
-        </p:spPr>
-        <p:txBody>
-          <a:bodyPr wrap="square" anchor="t" lIns="73152" rIns="73152" tIns="36576" bIns="36576">
-            <a:spAutoFit/>
-          </a:bodyPr>
-          <a:lstStyle/>
-          <a:p>
-            <a:pPr algn="l"/>
-            <a:r>
-              <a:rPr sz="1400" b="0">
-                <a:solidFill>
-                  <a:srgbClr val="26222E"/>
-                </a:solidFill>
-              </a:rPr>
-              <a:t>Commercial and technical definitions live once. Dynamics, ordering and billing consume them.</a:t>
-            </a:r>
-          </a:p>
-        </p:txBody>
-      </p:sp>
-      <p:sp>
-        <p:nvSpPr>
-          <p:cNvPr id="14" name="Rectangle 13"/>
-          <p:cNvSpPr/>
-          <p:nvPr/>
-        </p:nvSpPr>
-        <p:spPr>
-          <a:xfrm>
-            <a:off x="8046719" y="1371600"/>
-            <a:ext cx="3474720" cy="2194560"/>
-          </a:xfrm>
-          <a:prstGeom prst="rect">
-            <a:avLst/>
-          </a:prstGeom>
-          <a:solidFill>
-            <a:srgbClr val="E8F0F8"/>
-          </a:solidFill>
-          <a:ln>
-            <a:noFill/>
-          </a:ln>
-          <a:effectLst/>
-        </p:spPr>
-        <p:style>
-          <a:lnRef idx="1">
-            <a:schemeClr val="accent1"/>
-          </a:lnRef>
-          <a:fillRef idx="3">
-            <a:schemeClr val="accent1"/>
-          </a:fillRef>
-          <a:effectRef idx="2">
-            <a:schemeClr val="accent1"/>
-          </a:effectRef>
-          <a:fontRef idx="minor">
-            <a:schemeClr val="lt1"/>
-          </a:fontRef>
-        </p:style>
-        <p:txBody>
-          <a:bodyPr rtlCol="0" anchor="ctr"/>
-          <a:lstStyle/>
-          <a:p>
-            <a:pPr algn="ctr"/>
-          </a:p>
-        </p:txBody>
-      </p:sp>
-      <p:sp>
-        <p:nvSpPr>
-          <p:cNvPr id="15" name="Rectangle 14"/>
-          <p:cNvSpPr/>
-          <p:nvPr/>
-        </p:nvSpPr>
-        <p:spPr>
-          <a:xfrm>
-            <a:off x="8046719" y="1371600"/>
-            <a:ext cx="3474720" cy="91440"/>
-          </a:xfrm>
-          <a:prstGeom prst="rect">
-            <a:avLst/>
-          </a:prstGeom>
-          <a:solidFill>
-            <a:srgbClr val="0C294B"/>
-          </a:solidFill>
-          <a:ln>
-            <a:noFill/>
-          </a:ln>
-          <a:effectLst/>
-        </p:spPr>
-        <p:style>
-          <a:lnRef idx="1">
-            <a:schemeClr val="accent1"/>
-          </a:lnRef>
-          <a:fillRef idx="3">
-            <a:schemeClr val="accent1"/>
-          </a:fillRef>
-          <a:effectRef idx="2">
-            <a:schemeClr val="accent1"/>
-          </a:effectRef>
-          <a:fontRef idx="minor">
-            <a:schemeClr val="lt1"/>
-          </a:fontRef>
-        </p:style>
-        <p:txBody>
-          <a:bodyPr rtlCol="0" anchor="ctr"/>
-          <a:lstStyle/>
-          <a:p>
-            <a:pPr algn="ctr"/>
-          </a:p>
-        </p:txBody>
-      </p:sp>
-      <p:sp>
-        <p:nvSpPr>
-          <p:cNvPr id="16" name="TextBox 15"/>
-          <p:cNvSpPr txBox="1"/>
-          <p:nvPr/>
-        </p:nvSpPr>
-        <p:spPr>
-          <a:xfrm>
-            <a:off x="8183879" y="1645920"/>
-            <a:ext cx="3200400" cy="502920"/>
-          </a:xfrm>
-          <a:prstGeom prst="rect">
-            <a:avLst/>
-          </a:prstGeom>
-          <a:noFill/>
-        </p:spPr>
-        <p:txBody>
-          <a:bodyPr wrap="square" anchor="t" lIns="73152" rIns="73152" tIns="36576" bIns="36576">
-            <a:spAutoFit/>
-          </a:bodyPr>
-          <a:lstStyle/>
-          <a:p>
-            <a:pPr algn="l"/>
-            <a:r>
-              <a:rPr sz="1800" b="1">
-                <a:solidFill>
-                  <a:srgbClr val="0C294B"/>
-                </a:solidFill>
-              </a:rPr>
-              <a:t>A governed journey</a:t>
-            </a:r>
-          </a:p>
-        </p:txBody>
-      </p:sp>
-      <p:sp>
-        <p:nvSpPr>
-          <p:cNvPr id="17" name="TextBox 16"/>
-          <p:cNvSpPr txBox="1"/>
-          <p:nvPr/>
-        </p:nvSpPr>
-        <p:spPr>
-          <a:xfrm>
-            <a:off x="8183879" y="2194560"/>
-            <a:ext cx="3200400" cy="1234440"/>
-          </a:xfrm>
-          <a:prstGeom prst="rect">
-            <a:avLst/>
-          </a:prstGeom>
-          <a:noFill/>
-        </p:spPr>
-        <p:txBody>
-          <a:bodyPr wrap="square" anchor="t" lIns="73152" rIns="73152" tIns="36576" bIns="36576">
-            <a:spAutoFit/>
-          </a:bodyPr>
-          <a:lstStyle/>
-          <a:p>
-            <a:pPr algn="l"/>
-            <a:r>
-              <a:rPr sz="1400" b="0">
-                <a:solidFill>
-                  <a:srgbClr val="26222E"/>
-                </a:solidFill>
-              </a:rPr>
-              <a:t>Ideation to end-of-life, with workflow, approvals, simulations and versioned change.</a:t>
-            </a:r>
-          </a:p>
-        </p:txBody>
-      </p:sp>
-      <p:sp>
-        <p:nvSpPr>
-          <p:cNvPr id="18" name="Rectangle 17"/>
-          <p:cNvSpPr/>
-          <p:nvPr/>
-        </p:nvSpPr>
-        <p:spPr>
-          <a:xfrm>
-            <a:off x="548640" y="3794760"/>
-            <a:ext cx="3474720" cy="2194560"/>
-          </a:xfrm>
-          <a:prstGeom prst="rect">
-            <a:avLst/>
-          </a:prstGeom>
-          <a:solidFill>
-            <a:srgbClr val="E8F0F8"/>
-          </a:solidFill>
-          <a:ln>
-            <a:noFill/>
-          </a:ln>
-          <a:effectLst/>
-        </p:spPr>
-        <p:style>
-          <a:lnRef idx="1">
-            <a:schemeClr val="accent1"/>
-          </a:lnRef>
-          <a:fillRef idx="3">
-            <a:schemeClr val="accent1"/>
-          </a:fillRef>
-          <a:effectRef idx="2">
-            <a:schemeClr val="accent1"/>
-          </a:effectRef>
-          <a:fontRef idx="minor">
-            <a:schemeClr val="lt1"/>
-          </a:fontRef>
-        </p:style>
-        <p:txBody>
-          <a:bodyPr rtlCol="0" anchor="ctr"/>
-          <a:lstStyle/>
-          <a:p>
-            <a:pPr algn="ctr"/>
-          </a:p>
-        </p:txBody>
-      </p:sp>
-      <p:sp>
-        <p:nvSpPr>
-          <p:cNvPr id="19" name="Rectangle 18"/>
-          <p:cNvSpPr/>
-          <p:nvPr/>
-        </p:nvSpPr>
-        <p:spPr>
-          <a:xfrm>
-            <a:off x="548640" y="3794760"/>
-            <a:ext cx="3474720" cy="91440"/>
-          </a:xfrm>
-          <a:prstGeom prst="rect">
-            <a:avLst/>
-          </a:prstGeom>
-          <a:solidFill>
-            <a:srgbClr val="0C294B"/>
-          </a:solidFill>
-          <a:ln>
-            <a:noFill/>
-          </a:ln>
-          <a:effectLst/>
-        </p:spPr>
-        <p:style>
-          <a:lnRef idx="1">
-            <a:schemeClr val="accent1"/>
-          </a:lnRef>
-          <a:fillRef idx="3">
-            <a:schemeClr val="accent1"/>
-          </a:fillRef>
-          <a:effectRef idx="2">
-            <a:schemeClr val="accent1"/>
-          </a:effectRef>
-          <a:fontRef idx="minor">
-            <a:schemeClr val="lt1"/>
-          </a:fontRef>
-        </p:style>
-        <p:txBody>
-          <a:bodyPr rtlCol="0" anchor="ctr"/>
-          <a:lstStyle/>
-          <a:p>
-            <a:pPr algn="ctr"/>
-          </a:p>
-        </p:txBody>
-      </p:sp>
-      <p:sp>
-        <p:nvSpPr>
-          <p:cNvPr id="20" name="TextBox 19"/>
-          <p:cNvSpPr txBox="1"/>
-          <p:nvPr/>
-        </p:nvSpPr>
-        <p:spPr>
-          <a:xfrm>
-            <a:off x="685800" y="4069080"/>
-            <a:ext cx="3200400" cy="502920"/>
-          </a:xfrm>
-          <a:prstGeom prst="rect">
-            <a:avLst/>
-          </a:prstGeom>
-          <a:noFill/>
-        </p:spPr>
-        <p:txBody>
-          <a:bodyPr wrap="square" anchor="t" lIns="73152" rIns="73152" tIns="36576" bIns="36576">
-            <a:spAutoFit/>
-          </a:bodyPr>
-          <a:lstStyle/>
-          <a:p>
-            <a:pPr algn="l"/>
-            <a:r>
-              <a:rPr sz="1800" b="1">
-                <a:solidFill>
-                  <a:srgbClr val="0C294B"/>
-                </a:solidFill>
-              </a:rPr>
-              <a:t>Business users configure</a:t>
-            </a:r>
-          </a:p>
-        </p:txBody>
-      </p:sp>
-      <p:sp>
-        <p:nvSpPr>
-          <p:cNvPr id="21" name="TextBox 20"/>
-          <p:cNvSpPr txBox="1"/>
-          <p:nvPr/>
-        </p:nvSpPr>
-        <p:spPr>
-          <a:xfrm>
-            <a:off x="685800" y="4617720"/>
-            <a:ext cx="3200400" cy="1234440"/>
-          </a:xfrm>
-          <a:prstGeom prst="rect">
-            <a:avLst/>
-          </a:prstGeom>
-          <a:noFill/>
-        </p:spPr>
-        <p:txBody>
-          <a:bodyPr wrap="square" anchor="t" lIns="73152" rIns="73152" tIns="36576" bIns="36576">
-            <a:spAutoFit/>
-          </a:bodyPr>
-          <a:lstStyle/>
-          <a:p>
-            <a:pPr algn="l"/>
-            <a:r>
-              <a:rPr sz="1400" b="0">
-                <a:solidFill>
-                  <a:srgbClr val="26222E"/>
-                </a:solidFill>
-              </a:rPr>
-              <a:t>Role-based UI, templates and building blocks. No code. No deployment overhead.</a:t>
-            </a:r>
-          </a:p>
-        </p:txBody>
-      </p:sp>
-      <p:sp>
-        <p:nvSpPr>
-          <p:cNvPr id="22" name="Rectangle 21"/>
-          <p:cNvSpPr/>
-          <p:nvPr/>
-        </p:nvSpPr>
-        <p:spPr>
-          <a:xfrm>
-            <a:off x="4297679" y="3794760"/>
-            <a:ext cx="3474720" cy="2194560"/>
-          </a:xfrm>
-          <a:prstGeom prst="rect">
-            <a:avLst/>
-          </a:prstGeom>
-          <a:solidFill>
-            <a:srgbClr val="E8F0F8"/>
-          </a:solidFill>
-          <a:ln>
-            <a:noFill/>
-          </a:ln>
-          <a:effectLst/>
-        </p:spPr>
-        <p:style>
-          <a:lnRef idx="1">
-            <a:schemeClr val="accent1"/>
-          </a:lnRef>
-          <a:fillRef idx="3">
-            <a:schemeClr val="accent1"/>
-          </a:fillRef>
-          <a:effectRef idx="2">
-            <a:schemeClr val="accent1"/>
-          </a:effectRef>
-          <a:fontRef idx="minor">
-            <a:schemeClr val="lt1"/>
-          </a:fontRef>
-        </p:style>
-        <p:txBody>
-          <a:bodyPr rtlCol="0" anchor="ctr"/>
-          <a:lstStyle/>
-          <a:p>
-            <a:pPr algn="ctr"/>
-          </a:p>
-        </p:txBody>
-      </p:sp>
-      <p:sp>
-        <p:nvSpPr>
-          <p:cNvPr id="23" name="Rectangle 22"/>
-          <p:cNvSpPr/>
-          <p:nvPr/>
-        </p:nvSpPr>
-        <p:spPr>
-          <a:xfrm>
-            <a:off x="4297679" y="3794760"/>
-            <a:ext cx="3474720" cy="91440"/>
-          </a:xfrm>
-          <a:prstGeom prst="rect">
-            <a:avLst/>
-          </a:prstGeom>
-          <a:solidFill>
-            <a:srgbClr val="0C294B"/>
-          </a:solidFill>
-          <a:ln>
-            <a:noFill/>
-          </a:ln>
-          <a:effectLst/>
-        </p:spPr>
-        <p:style>
-          <a:lnRef idx="1">
-            <a:schemeClr val="accent1"/>
-          </a:lnRef>
-          <a:fillRef idx="3">
-            <a:schemeClr val="accent1"/>
-          </a:fillRef>
-          <a:effectRef idx="2">
-            <a:schemeClr val="accent1"/>
-          </a:effectRef>
-          <a:fontRef idx="minor">
-            <a:schemeClr val="lt1"/>
-          </a:fontRef>
-        </p:style>
-        <p:txBody>
-          <a:bodyPr rtlCol="0" anchor="ctr"/>
-          <a:lstStyle/>
-          <a:p>
-            <a:pPr algn="ctr"/>
-          </a:p>
-        </p:txBody>
-      </p:sp>
-      <p:sp>
-        <p:nvSpPr>
-          <p:cNvPr id="24" name="TextBox 23"/>
-          <p:cNvSpPr txBox="1"/>
-          <p:nvPr/>
-        </p:nvSpPr>
-        <p:spPr>
-          <a:xfrm>
-            <a:off x="4434839" y="4069080"/>
-            <a:ext cx="3200400" cy="502920"/>
-          </a:xfrm>
-          <a:prstGeom prst="rect">
-            <a:avLst/>
-          </a:prstGeom>
-          <a:noFill/>
-        </p:spPr>
-        <p:txBody>
-          <a:bodyPr wrap="square" anchor="t" lIns="73152" rIns="73152" tIns="36576" bIns="36576">
-            <a:spAutoFit/>
-          </a:bodyPr>
-          <a:lstStyle/>
-          <a:p>
-            <a:pPr algn="l"/>
-            <a:r>
-              <a:rPr sz="1800" b="1">
-                <a:solidFill>
-                  <a:srgbClr val="0C294B"/>
-                </a:solidFill>
-              </a:rPr>
-              <a:t>Publish, do not re-key</a:t>
-            </a:r>
-          </a:p>
-        </p:txBody>
-      </p:sp>
-      <p:sp>
-        <p:nvSpPr>
-          <p:cNvPr id="25" name="TextBox 24"/>
-          <p:cNvSpPr txBox="1"/>
-          <p:nvPr/>
-        </p:nvSpPr>
-        <p:spPr>
-          <a:xfrm>
-            <a:off x="4434839" y="4617720"/>
-            <a:ext cx="3200400" cy="1234440"/>
-          </a:xfrm>
-          <a:prstGeom prst="rect">
-            <a:avLst/>
-          </a:prstGeom>
-          <a:noFill/>
-        </p:spPr>
-        <p:txBody>
-          <a:bodyPr wrap="square" anchor="t" lIns="73152" rIns="73152" tIns="36576" bIns="36576">
-            <a:spAutoFit/>
-          </a:bodyPr>
-          <a:lstStyle/>
-          <a:p>
-            <a:pPr algn="l"/>
-            <a:r>
-              <a:rPr sz="1400" b="0">
-                <a:solidFill>
-                  <a:srgbClr val="26222E"/>
-                </a:solidFill>
-              </a:rPr>
-              <a:t>Master catalog + Kafka + TMF620 events push Active products into Dynamics.</a:t>
-            </a:r>
-          </a:p>
-        </p:txBody>
-      </p:sp>
-      <p:sp>
-        <p:nvSpPr>
-          <p:cNvPr id="26" name="Rectangle 25"/>
-          <p:cNvSpPr/>
-          <p:nvPr/>
-        </p:nvSpPr>
-        <p:spPr>
-          <a:xfrm>
-            <a:off x="8046719" y="3794760"/>
-            <a:ext cx="3474720" cy="2194560"/>
-          </a:xfrm>
-          <a:prstGeom prst="rect">
-            <a:avLst/>
-          </a:prstGeom>
-          <a:solidFill>
-            <a:srgbClr val="E8F0F8"/>
-          </a:solidFill>
-          <a:ln>
-            <a:noFill/>
-          </a:ln>
-          <a:effectLst/>
-        </p:spPr>
-        <p:style>
-          <a:lnRef idx="1">
-            <a:schemeClr val="accent1"/>
-          </a:lnRef>
-          <a:fillRef idx="3">
-            <a:schemeClr val="accent1"/>
-          </a:fillRef>
-          <a:effectRef idx="2">
-            <a:schemeClr val="accent1"/>
-          </a:effectRef>
-          <a:fontRef idx="minor">
-            <a:schemeClr val="lt1"/>
-          </a:fontRef>
-        </p:style>
-        <p:txBody>
-          <a:bodyPr rtlCol="0" anchor="ctr"/>
-          <a:lstStyle/>
-          <a:p>
-            <a:pPr algn="ctr"/>
-          </a:p>
-        </p:txBody>
-      </p:sp>
-      <p:sp>
-        <p:nvSpPr>
-          <p:cNvPr id="27" name="Rectangle 26"/>
+          <p:cNvPr id="28" name="Rectangle 27"/>
           <p:cNvSpPr/>
           <p:nvPr/>
         </p:nvSpPr>
@@ -12673,14 +12912,14 @@
       </p:sp>
       <p:sp>
         <p:nvSpPr>
-          <p:cNvPr id="28" name="TextBox 27"/>
+          <p:cNvPr id="29" name="TextBox 28"/>
           <p:cNvSpPr txBox="1"/>
           <p:nvPr/>
         </p:nvSpPr>
         <p:spPr>
           <a:xfrm>
-            <a:off x="8183879" y="4069080"/>
-            <a:ext cx="3200400" cy="502920"/>
+            <a:off x="8183879" y="4023360"/>
+            <a:ext cx="3200400" cy="457200"/>
           </a:xfrm>
           <a:prstGeom prst="rect">
             <a:avLst/>
@@ -12695,7 +12934,7 @@
           <a:p>
             <a:pPr algn="l"/>
             <a:r>
-              <a:rPr sz="1800" b="1">
+              <a:rPr sz="1700" b="1">
                 <a:solidFill>
                   <a:srgbClr val="0C294B"/>
                 </a:solidFill>
@@ -12707,13 +12946,13 @@
       </p:sp>
       <p:sp>
         <p:nvSpPr>
-          <p:cNvPr id="29" name="TextBox 28"/>
+          <p:cNvPr id="30" name="TextBox 29"/>
           <p:cNvSpPr txBox="1"/>
           <p:nvPr/>
         </p:nvSpPr>
         <p:spPr>
           <a:xfrm>
-            <a:off x="8183879" y="4617720"/>
+            <a:off x="8183879" y="4526280"/>
             <a:ext cx="3200400" cy="1234440"/>
           </a:xfrm>
           <a:prstGeom prst="rect">
@@ -12729,7 +12968,7 @@
           <a:p>
             <a:pPr algn="l"/>
             <a:r>
-              <a:rPr sz="1400" b="0">
+              <a:rPr sz="1300" b="0">
                 <a:solidFill>
                   <a:srgbClr val="26222E"/>
                 </a:solidFill>
@@ -12864,7 +13103,7 @@
                   <a:srgbClr val="5F5A6B"/>
                 </a:solidFill>
               </a:rPr>
-              <a:t>TMF620 defines the statuses. CatalogONE PLM runs them. Dynamics only sees Active / Launched.</a:t>
+              <a:t>TMF620 defines the statuses. CatalogONE PLM runs them. CRM sees Active / Launched after publish.</a:t>
             </a:r>
           </a:p>
         </p:txBody>
@@ -12898,7 +13137,7 @@
                   <a:srgbClr val="5F5A6B"/>
                 </a:solidFill>
               </a:rPr>
-              <a:t>PLC study  |  Amdocs CatalogONE: from idea to Dynamics 365</a:t>
+              <a:t>PLC study  |  Amdocs CatalogONE: from idea to CRM</a:t>
             </a:r>
           </a:p>
         </p:txBody>
@@ -13967,7 +14206,7 @@
                   <a:srgbClr val="0078D4"/>
                 </a:solidFill>
               </a:rPr>
-              <a:t>Dynamics 365: visible to sales</a:t>
+              <a:t>Sales CRM: visible after publish</a:t>
             </a:r>
           </a:p>
         </p:txBody>
@@ -14131,7 +14370,7 @@
                   <a:srgbClr val="5F5A6B"/>
                 </a:solidFill>
               </a:rPr>
-              <a:t>Standalone telecom catalog + PLM. Modular. Does not replace Dynamics.</a:t>
+              <a:t>Standalone telecom catalog + PLM. Modular. Does not replace CRM.</a:t>
             </a:r>
           </a:p>
         </p:txBody>
@@ -14165,7 +14404,7 @@
                   <a:srgbClr val="5F5A6B"/>
                 </a:solidFill>
               </a:rPr>
-              <a:t>PLC study  |  Amdocs CatalogONE: from idea to Dynamics 365</a:t>
+              <a:t>PLC study  |  Amdocs CatalogONE: from idea to CRM</a:t>
             </a:r>
           </a:p>
         </p:txBody>
@@ -14819,7 +15058,7 @@
                   <a:srgbClr val="0C294B"/>
                 </a:solidFill>
               </a:rPr>
-              <a:t>Catalog is a module of its own. Sales is Dynamics 365.</a:t>
+              <a:t>Where Dynamics 365 is named: the Amdocs–Microsoft platform</a:t>
             </a:r>
           </a:p>
         </p:txBody>
@@ -14853,7 +15092,7 @@
                   <a:srgbClr val="5F5A6B"/>
                 </a:solidFill>
               </a:rPr>
-              <a:t>Amdocs–Microsoft Customer Engagement Platform: unified catalog + Dynamics CRM</a:t>
+              <a:t>CEP puts Catalog next to Dynamics. CatalogONE datasheets do not name Dynamics.</a:t>
             </a:r>
           </a:p>
         </p:txBody>
@@ -14887,7 +15126,7 @@
                   <a:srgbClr val="5F5A6B"/>
                 </a:solidFill>
               </a:rPr>
-              <a:t>PLC study  |  Amdocs CatalogONE: from idea to Dynamics 365</a:t>
+              <a:t>PLC study  |  Amdocs CatalogONE: from idea to CRM</a:t>
             </a:r>
           </a:p>
         </p:txBody>
@@ -15023,7 +15262,7 @@
                   <a:srgbClr val="5F5A6B"/>
                 </a:solidFill>
               </a:rPr>
-              <a:t>Source: Amdocs and Microsoft CEP paper, p.3</a:t>
+              <a:t>Source: Amdocs and Microsoft CEP paper, p.3 — this is CEP, not a CatalogONE datasheet</a:t>
             </a:r>
           </a:p>
         </p:txBody>
@@ -15213,7 +15452,7 @@
                   <a:srgbClr val="0C294B"/>
                 </a:solidFill>
               </a:rPr>
-              <a:t>Sales (Dynamics 365)</a:t>
+              <a:t>Sales / Service (Dynamics 365)</a:t>
             </a:r>
           </a:p>
         </p:txBody>
@@ -15247,7 +15486,7 @@
                   <a:srgbClr val="26222E"/>
                 </a:solidFill>
               </a:rPr>
-              <a:t>Quotes, orders, account managers. Consumes the catalog.</a:t>
+              <a:t>In CEP, quotes, orders and cases sit here. CRM is not replaced.</a:t>
             </a:r>
           </a:p>
         </p:txBody>
@@ -15325,7 +15564,7 @@
                   <a:srgbClr val="0C294B"/>
                 </a:solidFill>
               </a:rPr>
-              <a:t>Why it matters</a:t>
+              <a:t>Live operator: PLDT</a:t>
             </a:r>
           </a:p>
         </p:txBody>
@@ -15359,7 +15598,7 @@
                   <a:srgbClr val="26222E"/>
                 </a:solidFill>
               </a:rPr>
-              <a:t>CRM is not replaced. Approved products are published into it.</a:t>
+              <a:t>IDC 2026: case management on CEP. Agents use Dynamics 365. Care, not a CatalogONE catalog feed.</a:t>
             </a:r>
           </a:p>
         </p:txBody>
@@ -15523,7 +15762,7 @@
                   <a:srgbClr val="5F5A6B"/>
                 </a:solidFill>
               </a:rPr>
-              <a:t>PLC study  |  Amdocs CatalogONE: from idea to Dynamics 365</a:t>
+              <a:t>PLC study  |  Amdocs CatalogONE: from idea to CRM</a:t>
             </a:r>
           </a:p>
         </p:txBody>
@@ -16479,7 +16718,7 @@
                   <a:srgbClr val="5F5A6B"/>
                 </a:solidFill>
               </a:rPr>
-              <a:t>PLC study  |  Amdocs CatalogONE: from idea to Dynamics 365</a:t>
+              <a:t>PLC study  |  Amdocs CatalogONE: from idea to CRM</a:t>
             </a:r>
           </a:p>
         </p:txBody>
@@ -17773,7 +18012,7 @@
                   <a:srgbClr val="5F5A6B"/>
                 </a:solidFill>
               </a:rPr>
-              <a:t>PLC study  |  Amdocs CatalogONE: from idea to Dynamics 365</a:t>
+              <a:t>PLC study  |  Amdocs CatalogONE: from idea to CRM</a:t>
             </a:r>
           </a:p>
         </p:txBody>
@@ -18871,7 +19110,7 @@
                   <a:srgbClr val="26222E"/>
                 </a:solidFill>
               </a:rPr>
-              <a:t>Pass: Active, ready for Dynamics</a:t>
+              <a:t>Pass: Active, ready to publish</a:t>
             </a:r>
           </a:p>
           <a:p>

</xml_diff>

<commit_message>
Spell out CEP: Amdocs–Microsoft Customer Engagement Platform
Manager-facing wording: CEP is the packaged telecom CRM Amdocs and
Microsoft sell together, not a CatalogONE plug-in for existing Dynamics.

Co-authored-by: abdelrahman Hamdy <abdoe317111@gmail.com>
</commit_message>
<xml_diff>
--- a/plc_study/PLC_CatalogONE_Presentation.pptx
+++ b/plc_study/PLC_CatalogONE_Presentation.pptx
@@ -3883,7 +3883,7 @@
                   <a:srgbClr val="E8F0F8"/>
                 </a:solidFill>
               </a:rPr>
-              <a:t>Prepared by: [Your name]   |   October 2026   |   Draft 3</a:t>
+              <a:t>Prepared by: [Your name]   |   October 2026   |   Draft 4</a:t>
             </a:r>
           </a:p>
         </p:txBody>
@@ -8818,7 +8818,7 @@
                   <a:srgbClr val="5F5A6B"/>
                 </a:solidFill>
               </a:rPr>
-              <a:t>Pre-built Catalog+Dynamics is CEP. Not a CatalogONE AppSource connector.</a:t>
+              <a:t>Pre-built Catalog+Dynamics is the Customer Engagement Platform. Not a CatalogONE plug-in.</a:t>
             </a:r>
           </a:p>
         </p:txBody>
@@ -9142,7 +9142,7 @@
                   <a:srgbClr val="0C294B"/>
                 </a:solidFill>
               </a:rPr>
-              <a:t>Two paths: buy CEP (Catalog next to Dynamics, documented) or keep Dynamics and integrate via TMF620 / Kafka (CatalogONE pattern for any CRM).</a:t>
+              <a:t>Two paths: buy the Customer Engagement Platform, or keep Dynamics and integrate CatalogONE via TMF620 / Kafka.</a:t>
             </a:r>
           </a:p>
         </p:txBody>
@@ -10400,7 +10400,7 @@
               <a:buChar char="•"/>
             </a:pPr>
             <a:r>
-              <a:rPr b="1" sz="1500">
+              <a:rPr b="1" sz="1400">
                 <a:solidFill>
                   <a:srgbClr val="0C294B"/>
                 </a:solidFill>
@@ -10408,7 +10408,7 @@
               <a:t>Idea to Active </a:t>
             </a:r>
             <a:r>
-              <a:rPr sz="1500">
+              <a:rPr sz="1400">
                 <a:solidFill>
                   <a:srgbClr val="26222E"/>
                 </a:solidFill>
@@ -10424,7 +10424,7 @@
               <a:buChar char="•"/>
             </a:pPr>
             <a:r>
-              <a:rPr b="1" sz="1500">
+              <a:rPr b="1" sz="1400">
                 <a:solidFill>
                   <a:srgbClr val="0C294B"/>
                 </a:solidFill>
@@ -10432,7 +10432,7 @@
               <a:t>CatalogONE publishes </a:t>
             </a:r>
             <a:r>
-              <a:rPr sz="1500">
+              <a:rPr sz="1400">
                 <a:solidFill>
                   <a:srgbClr val="26222E"/>
                 </a:solidFill>
@@ -10448,20 +10448,20 @@
               <a:buChar char="•"/>
             </a:pPr>
             <a:r>
-              <a:rPr b="1" sz="1500">
+              <a:rPr b="1" sz="1400">
                 <a:solidFill>
                   <a:srgbClr val="0C294B"/>
                 </a:solidFill>
               </a:rPr>
-              <a:t>Dynamics 365 is named on CEP, </a:t>
-            </a:r>
-            <a:r>
-              <a:rPr sz="1500">
+              <a:t>Dynamics 365 is named on the Customer Engagement Platform, </a:t>
+            </a:r>
+            <a:r>
+              <a:rPr sz="1400">
                 <a:solidFill>
                   <a:srgbClr val="26222E"/>
                 </a:solidFill>
               </a:rPr>
-              <a:t>as Sales and Customer Service next to Catalog — not on the CatalogONE datasheet as a connector. PLDT is live on CEP care.</a:t>
+              <a:t>as Sales and Customer Service next to Catalog — not on the CatalogONE datasheet. PLDT is live on that platform for care.</a:t>
             </a:r>
           </a:p>
           <a:p>
@@ -10472,7 +10472,7 @@
               <a:buChar char="•"/>
             </a:pPr>
             <a:r>
-              <a:rPr b="1" sz="1500">
+              <a:rPr b="1" sz="1400">
                 <a:solidFill>
                   <a:srgbClr val="0C294B"/>
                 </a:solidFill>
@@ -10480,12 +10480,12 @@
               <a:t>Two paths: </a:t>
             </a:r>
             <a:r>
-              <a:rPr sz="1500">
+              <a:rPr sz="1400">
                 <a:solidFill>
                   <a:srgbClr val="26222E"/>
                 </a:solidFill>
               </a:rPr>
-              <a:t>buy CEP, or keep Dynamics and integrate via TMF620. CRM is not replaced.</a:t>
+              <a:t>buy the Customer Engagement Platform, or keep Dynamics and integrate CatalogONE via TMF620. CRM is not replaced.</a:t>
             </a:r>
           </a:p>
           <a:p>
@@ -10496,7 +10496,7 @@
               <a:buChar char="•"/>
             </a:pPr>
             <a:r>
-              <a:rPr b="1" sz="1500">
+              <a:rPr b="1" sz="1400">
                 <a:solidFill>
                   <a:srgbClr val="0C294B"/>
                 </a:solidFill>
@@ -10504,7 +10504,7 @@
               <a:t>Changes are versioned, </a:t>
             </a:r>
             <a:r>
-              <a:rPr sz="1500">
+              <a:rPr sz="1400">
                 <a:solidFill>
                   <a:srgbClr val="26222E"/>
                 </a:solidFill>
@@ -10520,7 +10520,7 @@
               <a:buChar char="•"/>
             </a:pPr>
             <a:r>
-              <a:rPr b="1" sz="1500">
+              <a:rPr b="1" sz="1400">
                 <a:solidFill>
                   <a:srgbClr val="0C294B"/>
                 </a:solidFill>
@@ -10528,12 +10528,12 @@
               <a:t>Proven CatalogONE </a:t>
             </a:r>
             <a:r>
-              <a:rPr sz="1500">
+              <a:rPr sz="1400">
                 <a:solidFill>
                   <a:srgbClr val="26222E"/>
                 </a:solidFill>
               </a:rPr>
-              <a:t>at a European quad-play, Sprint / T-Mobile and KT. CEP + Dynamics 365 is live at PLDT for case management.</a:t>
+              <a:t>at a European quad-play, Sprint / T-Mobile and KT. Customer Engagement Platform + Dynamics 365 is live at PLDT for case management.</a:t>
             </a:r>
           </a:p>
         </p:txBody>
@@ -11693,7 +11693,7 @@
                   <a:srgbClr val="5F5A6B"/>
                 </a:solidFill>
               </a:rPr>
-              <a:t>CatalogONE vs CEP vs Dynamics</a:t>
+              <a:t>CatalogONE vs Customer Engagement Platform</a:t>
             </a:r>
           </a:p>
         </p:txBody>
@@ -11969,7 +11969,7 @@
                   <a:srgbClr val="5F5A6B"/>
                 </a:solidFill>
               </a:rPr>
-              <a:t>Two facts, kept separate: CatalogONE publishes to CRM. CEP names Dynamics 365.</a:t>
+              <a:t>Two facts, kept separate: CatalogONE publishes to CRM. The Customer Engagement Platform names Dynamics 365.</a:t>
             </a:r>
           </a:p>
         </p:txBody>
@@ -12817,7 +12817,7 @@
                   <a:srgbClr val="26222E"/>
                 </a:solidFill>
               </a:rPr>
-              <a:t>Kafka + TMF620 to consuming applications. Dynamics 365 is named on CEP, not on the CatalogONE datasheet.</a:t>
+              <a:t>Kafka + TMF620 to consuming applications. Dynamics 365 is named on the Amdocs–Microsoft platform, not on CatalogONE.</a:t>
             </a:r>
           </a:p>
         </p:txBody>
@@ -15058,7 +15058,7 @@
                   <a:srgbClr val="0C294B"/>
                 </a:solidFill>
               </a:rPr>
-              <a:t>Where Dynamics 365 is named: the Amdocs–Microsoft platform</a:t>
+              <a:t>Where Dynamics 365 is named: Customer Engagement Platform (CEP)</a:t>
             </a:r>
           </a:p>
         </p:txBody>
@@ -15092,7 +15092,7 @@
                   <a:srgbClr val="5F5A6B"/>
                 </a:solidFill>
               </a:rPr>
-              <a:t>CEP puts Catalog next to Dynamics. CatalogONE datasheets do not name Dynamics.</a:t>
+              <a:t>CEP = Amdocs catalog + CPQ + commerce + OM, on Dynamics 365. Not a CatalogONE plug-in.</a:t>
             </a:r>
           </a:p>
         </p:txBody>

</xml_diff>